<commit_message>
updated link to andorid docu for avd path
</commit_message>
<xml_diff>
--- a/Preparation-Bay-Area-Workshop.pptx
+++ b/Preparation-Bay-Area-Workshop.pptx
@@ -14,18 +14,19 @@
     <p:sldId id="280" r:id="rId8"/>
     <p:sldId id="285" r:id="rId9"/>
     <p:sldId id="286" r:id="rId10"/>
-    <p:sldId id="282" r:id="rId11"/>
-    <p:sldId id="287" r:id="rId12"/>
-    <p:sldId id="262" r:id="rId13"/>
-    <p:sldId id="265" r:id="rId14"/>
-    <p:sldId id="269" r:id="rId15"/>
-    <p:sldId id="271" r:id="rId16"/>
-    <p:sldId id="270" r:id="rId17"/>
-    <p:sldId id="288" r:id="rId18"/>
-    <p:sldId id="277" r:id="rId19"/>
-    <p:sldId id="273" r:id="rId20"/>
-    <p:sldId id="274" r:id="rId21"/>
-    <p:sldId id="275" r:id="rId22"/>
+    <p:sldId id="289" r:id="rId11"/>
+    <p:sldId id="282" r:id="rId12"/>
+    <p:sldId id="287" r:id="rId13"/>
+    <p:sldId id="262" r:id="rId14"/>
+    <p:sldId id="265" r:id="rId15"/>
+    <p:sldId id="269" r:id="rId16"/>
+    <p:sldId id="271" r:id="rId17"/>
+    <p:sldId id="270" r:id="rId18"/>
+    <p:sldId id="288" r:id="rId19"/>
+    <p:sldId id="277" r:id="rId20"/>
+    <p:sldId id="273" r:id="rId21"/>
+    <p:sldId id="274" r:id="rId22"/>
+    <p:sldId id="275" r:id="rId23"/>
   </p:sldIdLst>
   <p:sldSz cx="12192000" cy="6858000"/>
   <p:notesSz cx="6858000" cy="9144000"/>
@@ -279,7 +280,7 @@
           <a:p>
             <a:fld id="{EE5AE19D-5FC0-AE43-B301-8386B09B318A}" type="datetimeFigureOut">
               <a:rPr lang="en-US" smtClean="0"/>
-              <a:t>10/5/18</a:t>
+              <a:t>10/10/18</a:t>
             </a:fld>
             <a:endParaRPr lang="en-US" dirty="0"/>
           </a:p>
@@ -333,7 +334,7 @@
           <a:p>
             <a:fld id="{450E0E0F-8177-3A46-925D-76643B592937}" type="slidenum">
               <a:rPr lang="en-US" smtClean="0"/>
-              <a:t>‹nr.›</a:t>
+              <a:t>‹#›</a:t>
             </a:fld>
             <a:endParaRPr lang="en-US" dirty="0"/>
           </a:p>
@@ -477,7 +478,7 @@
           <a:p>
             <a:fld id="{EE5AE19D-5FC0-AE43-B301-8386B09B318A}" type="datetimeFigureOut">
               <a:rPr lang="en-US" smtClean="0"/>
-              <a:t>10/5/18</a:t>
+              <a:t>10/10/18</a:t>
             </a:fld>
             <a:endParaRPr lang="en-US" dirty="0"/>
           </a:p>
@@ -531,7 +532,7 @@
           <a:p>
             <a:fld id="{450E0E0F-8177-3A46-925D-76643B592937}" type="slidenum">
               <a:rPr lang="en-US" smtClean="0"/>
-              <a:t>‹nr.›</a:t>
+              <a:t>‹#›</a:t>
             </a:fld>
             <a:endParaRPr lang="en-US" dirty="0"/>
           </a:p>
@@ -685,7 +686,7 @@
           <a:p>
             <a:fld id="{EE5AE19D-5FC0-AE43-B301-8386B09B318A}" type="datetimeFigureOut">
               <a:rPr lang="en-US" smtClean="0"/>
-              <a:t>10/5/18</a:t>
+              <a:t>10/10/18</a:t>
             </a:fld>
             <a:endParaRPr lang="en-US" dirty="0"/>
           </a:p>
@@ -739,7 +740,7 @@
           <a:p>
             <a:fld id="{450E0E0F-8177-3A46-925D-76643B592937}" type="slidenum">
               <a:rPr lang="en-US" smtClean="0"/>
-              <a:t>‹nr.›</a:t>
+              <a:t>‹#›</a:t>
             </a:fld>
             <a:endParaRPr lang="en-US" dirty="0"/>
           </a:p>
@@ -883,7 +884,7 @@
           <a:p>
             <a:fld id="{EE5AE19D-5FC0-AE43-B301-8386B09B318A}" type="datetimeFigureOut">
               <a:rPr lang="en-US" smtClean="0"/>
-              <a:t>10/5/18</a:t>
+              <a:t>10/10/18</a:t>
             </a:fld>
             <a:endParaRPr lang="en-US" dirty="0"/>
           </a:p>
@@ -937,7 +938,7 @@
           <a:p>
             <a:fld id="{450E0E0F-8177-3A46-925D-76643B592937}" type="slidenum">
               <a:rPr lang="en-US" smtClean="0"/>
-              <a:t>‹nr.›</a:t>
+              <a:t>‹#›</a:t>
             </a:fld>
             <a:endParaRPr lang="en-US" dirty="0"/>
           </a:p>
@@ -1158,7 +1159,7 @@
           <a:p>
             <a:fld id="{EE5AE19D-5FC0-AE43-B301-8386B09B318A}" type="datetimeFigureOut">
               <a:rPr lang="en-US" smtClean="0"/>
-              <a:t>10/5/18</a:t>
+              <a:t>10/10/18</a:t>
             </a:fld>
             <a:endParaRPr lang="en-US" dirty="0"/>
           </a:p>
@@ -1212,7 +1213,7 @@
           <a:p>
             <a:fld id="{450E0E0F-8177-3A46-925D-76643B592937}" type="slidenum">
               <a:rPr lang="en-US" smtClean="0"/>
-              <a:t>‹nr.›</a:t>
+              <a:t>‹#›</a:t>
             </a:fld>
             <a:endParaRPr lang="en-US" dirty="0"/>
           </a:p>
@@ -1423,7 +1424,7 @@
           <a:p>
             <a:fld id="{EE5AE19D-5FC0-AE43-B301-8386B09B318A}" type="datetimeFigureOut">
               <a:rPr lang="en-US" smtClean="0"/>
-              <a:t>10/5/18</a:t>
+              <a:t>10/10/18</a:t>
             </a:fld>
             <a:endParaRPr lang="en-US" dirty="0"/>
           </a:p>
@@ -1477,7 +1478,7 @@
           <a:p>
             <a:fld id="{450E0E0F-8177-3A46-925D-76643B592937}" type="slidenum">
               <a:rPr lang="en-US" smtClean="0"/>
-              <a:t>‹nr.›</a:t>
+              <a:t>‹#›</a:t>
             </a:fld>
             <a:endParaRPr lang="en-US" dirty="0"/>
           </a:p>
@@ -1835,7 +1836,7 @@
           <a:p>
             <a:fld id="{EE5AE19D-5FC0-AE43-B301-8386B09B318A}" type="datetimeFigureOut">
               <a:rPr lang="en-US" smtClean="0"/>
-              <a:t>10/5/18</a:t>
+              <a:t>10/10/18</a:t>
             </a:fld>
             <a:endParaRPr lang="en-US" dirty="0"/>
           </a:p>
@@ -1889,7 +1890,7 @@
           <a:p>
             <a:fld id="{450E0E0F-8177-3A46-925D-76643B592937}" type="slidenum">
               <a:rPr lang="en-US" smtClean="0"/>
-              <a:t>‹nr.›</a:t>
+              <a:t>‹#›</a:t>
             </a:fld>
             <a:endParaRPr lang="en-US" dirty="0"/>
           </a:p>
@@ -1976,7 +1977,7 @@
           <a:p>
             <a:fld id="{EE5AE19D-5FC0-AE43-B301-8386B09B318A}" type="datetimeFigureOut">
               <a:rPr lang="en-US" smtClean="0"/>
-              <a:t>10/5/18</a:t>
+              <a:t>10/10/18</a:t>
             </a:fld>
             <a:endParaRPr lang="en-US" dirty="0"/>
           </a:p>
@@ -2030,7 +2031,7 @@
           <a:p>
             <a:fld id="{450E0E0F-8177-3A46-925D-76643B592937}" type="slidenum">
               <a:rPr lang="en-US" smtClean="0"/>
-              <a:t>‹nr.›</a:t>
+              <a:t>‹#›</a:t>
             </a:fld>
             <a:endParaRPr lang="en-US" dirty="0"/>
           </a:p>
@@ -2089,7 +2090,7 @@
           <a:p>
             <a:fld id="{EE5AE19D-5FC0-AE43-B301-8386B09B318A}" type="datetimeFigureOut">
               <a:rPr lang="en-US" smtClean="0"/>
-              <a:t>10/5/18</a:t>
+              <a:t>10/10/18</a:t>
             </a:fld>
             <a:endParaRPr lang="en-US" dirty="0"/>
           </a:p>
@@ -2143,7 +2144,7 @@
           <a:p>
             <a:fld id="{450E0E0F-8177-3A46-925D-76643B592937}" type="slidenum">
               <a:rPr lang="en-US" smtClean="0"/>
-              <a:t>‹nr.›</a:t>
+              <a:t>‹#›</a:t>
             </a:fld>
             <a:endParaRPr lang="en-US" dirty="0"/>
           </a:p>
@@ -2400,7 +2401,7 @@
           <a:p>
             <a:fld id="{EE5AE19D-5FC0-AE43-B301-8386B09B318A}" type="datetimeFigureOut">
               <a:rPr lang="en-US" smtClean="0"/>
-              <a:t>10/5/18</a:t>
+              <a:t>10/10/18</a:t>
             </a:fld>
             <a:endParaRPr lang="en-US" dirty="0"/>
           </a:p>
@@ -2454,7 +2455,7 @@
           <a:p>
             <a:fld id="{450E0E0F-8177-3A46-925D-76643B592937}" type="slidenum">
               <a:rPr lang="en-US" smtClean="0"/>
-              <a:t>‹nr.›</a:t>
+              <a:t>‹#›</a:t>
             </a:fld>
             <a:endParaRPr lang="en-US" dirty="0"/>
           </a:p>
@@ -2688,7 +2689,7 @@
           <a:p>
             <a:fld id="{EE5AE19D-5FC0-AE43-B301-8386B09B318A}" type="datetimeFigureOut">
               <a:rPr lang="en-US" smtClean="0"/>
-              <a:t>10/5/18</a:t>
+              <a:t>10/10/18</a:t>
             </a:fld>
             <a:endParaRPr lang="en-US" dirty="0"/>
           </a:p>
@@ -2742,7 +2743,7 @@
           <a:p>
             <a:fld id="{450E0E0F-8177-3A46-925D-76643B592937}" type="slidenum">
               <a:rPr lang="en-US" smtClean="0"/>
-              <a:t>‹nr.›</a:t>
+              <a:t>‹#›</a:t>
             </a:fld>
             <a:endParaRPr lang="en-US" dirty="0"/>
           </a:p>
@@ -2929,7 +2930,7 @@
           <a:p>
             <a:fld id="{EE5AE19D-5FC0-AE43-B301-8386B09B318A}" type="datetimeFigureOut">
               <a:rPr lang="en-US" smtClean="0"/>
-              <a:t>10/5/18</a:t>
+              <a:t>10/10/18</a:t>
             </a:fld>
             <a:endParaRPr lang="en-US" dirty="0"/>
           </a:p>
@@ -3019,7 +3020,7 @@
           <a:p>
             <a:fld id="{450E0E0F-8177-3A46-925D-76643B592937}" type="slidenum">
               <a:rPr lang="en-US" smtClean="0"/>
-              <a:t>‹nr.›</a:t>
+              <a:t>‹#›</a:t>
             </a:fld>
             <a:endParaRPr lang="en-US" dirty="0"/>
           </a:p>
@@ -3457,12 +3458,64 @@
           </a:p>
         </p:txBody>
       </p:sp>
+      <p:sp>
+        <p:nvSpPr>
+          <p:cNvPr id="8" name="Content Placeholder 2">
+            <a:extLst>
+              <a:ext uri="{FF2B5EF4-FFF2-40B4-BE49-F238E27FC236}">
+                <a16:creationId xmlns:a16="http://schemas.microsoft.com/office/drawing/2014/main" id="{0D2DE8F7-0E7C-D843-9AC3-F71A174D49D9}"/>
+              </a:ext>
+            </a:extLst>
+          </p:cNvPr>
+          <p:cNvSpPr>
+            <a:spLocks noGrp="1"/>
+          </p:cNvSpPr>
+          <p:nvPr>
+            <p:ph idx="1"/>
+          </p:nvPr>
+        </p:nvSpPr>
+        <p:spPr>
+          <a:xfrm>
+            <a:off x="838200" y="1825625"/>
+            <a:ext cx="11071860" cy="4351338"/>
+          </a:xfrm>
+        </p:spPr>
+        <p:txBody>
+          <a:bodyPr>
+            <a:normAutofit/>
+          </a:bodyPr>
+          <a:lstStyle/>
+          <a:p>
+            <a:pPr marL="0" indent="0">
+              <a:buNone/>
+            </a:pPr>
+            <a:r>
+              <a:rPr lang="en-US" dirty="0"/>
+              <a:t>Additionally you need to replace the paths in </a:t>
+            </a:r>
+            <a:r>
+              <a:rPr lang="en-US" dirty="0" err="1"/>
+              <a:t>hardware.ini</a:t>
+            </a:r>
+            <a:r>
+              <a:rPr lang="en-US" dirty="0"/>
+              <a:t> with your own</a:t>
+            </a:r>
+          </a:p>
+          <a:p>
+            <a:pPr marL="0" indent="0">
+              <a:buNone/>
+            </a:pPr>
+            <a:endParaRPr lang="en-US" dirty="0"/>
+          </a:p>
+        </p:txBody>
+      </p:sp>
       <p:pic>
         <p:nvPicPr>
           <p:cNvPr id="4" name="Picture 3">
             <a:extLst>
               <a:ext uri="{FF2B5EF4-FFF2-40B4-BE49-F238E27FC236}">
-                <a16:creationId xmlns:a16="http://schemas.microsoft.com/office/drawing/2014/main" id="{6A1A2CD8-F5E5-DC41-B87F-F8DE0E56F90C}"/>
+                <a16:creationId xmlns:a16="http://schemas.microsoft.com/office/drawing/2014/main" id="{E461C1BE-8B11-1E40-8836-A6573BD28AFB}"/>
               </a:ext>
             </a:extLst>
           </p:cNvPr>
@@ -3479,94 +3532,20 @@
         </p:blipFill>
         <p:spPr>
           <a:xfrm>
-            <a:off x="5434149" y="1547949"/>
-            <a:ext cx="6551521" cy="5310051"/>
+            <a:off x="962660" y="2407444"/>
+            <a:ext cx="5506720" cy="2014849"/>
           </a:xfrm>
           <a:prstGeom prst="rect">
             <a:avLst/>
           </a:prstGeom>
         </p:spPr>
       </p:pic>
-      <p:sp>
-        <p:nvSpPr>
-          <p:cNvPr id="3" name="TextBox 2">
-            <a:extLst>
-              <a:ext uri="{FF2B5EF4-FFF2-40B4-BE49-F238E27FC236}">
-                <a16:creationId xmlns:a16="http://schemas.microsoft.com/office/drawing/2014/main" id="{EEF5B2E1-FE6E-A44E-8F22-61F4DD0D7F88}"/>
-              </a:ext>
-            </a:extLst>
-          </p:cNvPr>
-          <p:cNvSpPr txBox="1"/>
-          <p:nvPr/>
-        </p:nvSpPr>
-        <p:spPr>
-          <a:xfrm>
-            <a:off x="414592" y="1993217"/>
-            <a:ext cx="4935583" cy="2308324"/>
-          </a:xfrm>
-          <a:prstGeom prst="rect">
-            <a:avLst/>
-          </a:prstGeom>
-          <a:noFill/>
-        </p:spPr>
-        <p:txBody>
-          <a:bodyPr wrap="square" rtlCol="0">
-            <a:spAutoFit/>
-          </a:bodyPr>
-          <a:lstStyle/>
-          <a:p>
-            <a:r>
-              <a:rPr lang="en-US" b="1" dirty="0"/>
-              <a:t>Please make sure that the image for the AVD is downloaded. </a:t>
-            </a:r>
-          </a:p>
-          <a:p>
-            <a:endParaRPr lang="en-US" dirty="0"/>
-          </a:p>
-          <a:p>
-            <a:pPr marL="342900" indent="-342900">
-              <a:buAutoNum type="arabicPeriod"/>
-            </a:pPr>
-            <a:r>
-              <a:rPr lang="en-US" dirty="0"/>
-              <a:t>Go to Android Studio </a:t>
-            </a:r>
-          </a:p>
-          <a:p>
-            <a:pPr marL="342900" indent="-342900">
-              <a:buAutoNum type="arabicPeriod"/>
-            </a:pPr>
-            <a:r>
-              <a:rPr lang="en-US" dirty="0"/>
-              <a:t>Go to Tools / AVD Manager</a:t>
-            </a:r>
-          </a:p>
-          <a:p>
-            <a:pPr marL="342900" indent="-342900">
-              <a:buAutoNum type="arabicPeriod"/>
-            </a:pPr>
-            <a:r>
-              <a:rPr lang="en-US" dirty="0"/>
-              <a:t>Select 80x86 and click on Download</a:t>
-            </a:r>
-          </a:p>
-          <a:p>
-            <a:pPr marL="342900" indent="-342900">
-              <a:buAutoNum type="arabicPeriod"/>
-            </a:pPr>
-            <a:r>
-              <a:rPr lang="en-US" dirty="0"/>
-              <a:t>The system image used by this AVD will now be downloaded, if it wasn’t downloaded before</a:t>
-            </a:r>
-          </a:p>
-        </p:txBody>
-      </p:sp>
       <p:pic>
         <p:nvPicPr>
-          <p:cNvPr id="5" name="Picture 4">
-            <a:extLst>
-              <a:ext uri="{FF2B5EF4-FFF2-40B4-BE49-F238E27FC236}">
-                <a16:creationId xmlns:a16="http://schemas.microsoft.com/office/drawing/2014/main" id="{D693E95F-ADEE-7549-B7C7-67C99F1C5581}"/>
+          <p:cNvPr id="10" name="Picture 9">
+            <a:extLst>
+              <a:ext uri="{FF2B5EF4-FFF2-40B4-BE49-F238E27FC236}">
+                <a16:creationId xmlns:a16="http://schemas.microsoft.com/office/drawing/2014/main" id="{FAE6DCE2-A037-354D-AFDC-BBE3EBFAE741}"/>
               </a:ext>
             </a:extLst>
           </p:cNvPr>
@@ -3583,8 +3562,8 @@
         </p:blipFill>
         <p:spPr>
           <a:xfrm>
-            <a:off x="473375" y="4327072"/>
-            <a:ext cx="4876800" cy="1600200"/>
+            <a:off x="962660" y="4779658"/>
+            <a:ext cx="9721850" cy="1618601"/>
           </a:xfrm>
           <a:prstGeom prst="rect">
             <a:avLst/>
@@ -3594,7 +3573,7 @@
     </p:spTree>
     <p:extLst>
       <p:ext uri="{BB962C8B-B14F-4D97-AF65-F5344CB8AC3E}">
-        <p14:creationId xmlns:p14="http://schemas.microsoft.com/office/powerpoint/2010/main" val="3261444337"/>
+        <p14:creationId xmlns:p14="http://schemas.microsoft.com/office/powerpoint/2010/main" val="3918345310"/>
       </p:ext>
     </p:extLst>
   </p:cSld>
@@ -3649,126 +3628,12 @@
           </a:p>
         </p:txBody>
       </p:sp>
-      <p:sp>
-        <p:nvSpPr>
-          <p:cNvPr id="3" name="TextBox 2">
-            <a:extLst>
-              <a:ext uri="{FF2B5EF4-FFF2-40B4-BE49-F238E27FC236}">
-                <a16:creationId xmlns:a16="http://schemas.microsoft.com/office/drawing/2014/main" id="{EEF5B2E1-FE6E-A44E-8F22-61F4DD0D7F88}"/>
-              </a:ext>
-            </a:extLst>
-          </p:cNvPr>
-          <p:cNvSpPr txBox="1"/>
-          <p:nvPr/>
-        </p:nvSpPr>
-        <p:spPr>
-          <a:xfrm>
-            <a:off x="307793" y="1595739"/>
-            <a:ext cx="5074104" cy="3970318"/>
-          </a:xfrm>
-          <a:prstGeom prst="rect">
-            <a:avLst/>
-          </a:prstGeom>
-          <a:noFill/>
-        </p:spPr>
-        <p:txBody>
-          <a:bodyPr wrap="square" rtlCol="0">
-            <a:spAutoFit/>
-          </a:bodyPr>
-          <a:lstStyle/>
-          <a:p>
-            <a:r>
-              <a:rPr lang="en-US" b="1" dirty="0"/>
-              <a:t>Next we start our AVD</a:t>
-            </a:r>
-          </a:p>
-          <a:p>
-            <a:endParaRPr lang="en-US" dirty="0"/>
-          </a:p>
-          <a:p>
-            <a:pPr marL="342900" indent="-342900">
-              <a:buAutoNum type="arabicPeriod"/>
-            </a:pPr>
-            <a:r>
-              <a:rPr lang="en-US" dirty="0"/>
-              <a:t>Go to the Android SDK directory and go tools. There you will find the ‘emulator’ command. It’s located in: /Users/</a:t>
-            </a:r>
-            <a:r>
-              <a:rPr lang="en-US" dirty="0" err="1"/>
-              <a:t>sven</a:t>
-            </a:r>
-            <a:r>
-              <a:rPr lang="en-US" dirty="0"/>
-              <a:t>/Library/Android/</a:t>
-            </a:r>
-            <a:r>
-              <a:rPr lang="en-US" dirty="0" err="1"/>
-              <a:t>sdk</a:t>
-            </a:r>
-            <a:r>
-              <a:rPr lang="en-US" dirty="0"/>
-              <a:t>/tools (macOS) </a:t>
-            </a:r>
-          </a:p>
-          <a:p>
-            <a:pPr marL="342900" indent="-342900">
-              <a:buAutoNum type="arabicPeriod"/>
-            </a:pPr>
-            <a:endParaRPr lang="en-US" dirty="0"/>
-          </a:p>
-          <a:p>
-            <a:pPr marL="342900" indent="-342900">
-              <a:buAutoNum type="arabicPeriod"/>
-            </a:pPr>
-            <a:r>
-              <a:rPr lang="en-US" dirty="0"/>
-              <a:t>Let’s start our emulator with two custom flags</a:t>
-            </a:r>
-          </a:p>
-          <a:p>
-            <a:pPr marL="342900" indent="-342900">
-              <a:buAutoNum type="arabicPeriod"/>
-            </a:pPr>
-            <a:endParaRPr lang="en-US" dirty="0"/>
-          </a:p>
-          <a:p>
-            <a:pPr marL="342900" indent="-342900">
-              <a:buAutoNum type="arabicPeriod"/>
-            </a:pPr>
-            <a:r>
-              <a:rPr lang="en-US" dirty="0"/>
-              <a:t>In case you get an error like this, set the ANDROID_SDK_ROOT</a:t>
-            </a:r>
-          </a:p>
-          <a:p>
-            <a:pPr marL="342900" indent="-342900">
-              <a:buAutoNum type="arabicPeriod"/>
-            </a:pPr>
-            <a:endParaRPr lang="en-US" dirty="0"/>
-          </a:p>
-          <a:p>
-            <a:pPr marL="342900" indent="-342900">
-              <a:buAutoNum type="arabicPeriod"/>
-            </a:pPr>
-            <a:endParaRPr lang="en-US" dirty="0"/>
-          </a:p>
-          <a:p>
-            <a:pPr marL="342900" indent="-342900">
-              <a:buAutoNum type="arabicPeriod"/>
-            </a:pPr>
-            <a:r>
-              <a:rPr lang="en-US" dirty="0"/>
-              <a:t>Let’s start the AVD</a:t>
-            </a:r>
-          </a:p>
-        </p:txBody>
-      </p:sp>
       <p:pic>
         <p:nvPicPr>
-          <p:cNvPr id="6" name="Picture 5">
-            <a:extLst>
-              <a:ext uri="{FF2B5EF4-FFF2-40B4-BE49-F238E27FC236}">
-                <a16:creationId xmlns:a16="http://schemas.microsoft.com/office/drawing/2014/main" id="{977544D5-6DA7-3247-89BB-8C7DCC6EAF63}"/>
+          <p:cNvPr id="4" name="Picture 3">
+            <a:extLst>
+              <a:ext uri="{FF2B5EF4-FFF2-40B4-BE49-F238E27FC236}">
+                <a16:creationId xmlns:a16="http://schemas.microsoft.com/office/drawing/2014/main" id="{6A1A2CD8-F5E5-DC41-B87F-F8DE0E56F90C}"/>
               </a:ext>
             </a:extLst>
           </p:cNvPr>
@@ -3785,20 +3650,94 @@
         </p:blipFill>
         <p:spPr>
           <a:xfrm>
-            <a:off x="5243376" y="2305401"/>
-            <a:ext cx="7434984" cy="397148"/>
+            <a:off x="5434149" y="1547949"/>
+            <a:ext cx="6551521" cy="5310051"/>
           </a:xfrm>
           <a:prstGeom prst="rect">
             <a:avLst/>
           </a:prstGeom>
         </p:spPr>
       </p:pic>
+      <p:sp>
+        <p:nvSpPr>
+          <p:cNvPr id="3" name="TextBox 2">
+            <a:extLst>
+              <a:ext uri="{FF2B5EF4-FFF2-40B4-BE49-F238E27FC236}">
+                <a16:creationId xmlns:a16="http://schemas.microsoft.com/office/drawing/2014/main" id="{EEF5B2E1-FE6E-A44E-8F22-61F4DD0D7F88}"/>
+              </a:ext>
+            </a:extLst>
+          </p:cNvPr>
+          <p:cNvSpPr txBox="1"/>
+          <p:nvPr/>
+        </p:nvSpPr>
+        <p:spPr>
+          <a:xfrm>
+            <a:off x="414592" y="1993217"/>
+            <a:ext cx="4935583" cy="2308324"/>
+          </a:xfrm>
+          <a:prstGeom prst="rect">
+            <a:avLst/>
+          </a:prstGeom>
+          <a:noFill/>
+        </p:spPr>
+        <p:txBody>
+          <a:bodyPr wrap="square" rtlCol="0">
+            <a:spAutoFit/>
+          </a:bodyPr>
+          <a:lstStyle/>
+          <a:p>
+            <a:r>
+              <a:rPr lang="en-US" b="1" dirty="0"/>
+              <a:t>Please make sure that the image for the AVD is downloaded. </a:t>
+            </a:r>
+          </a:p>
+          <a:p>
+            <a:endParaRPr lang="en-US" dirty="0"/>
+          </a:p>
+          <a:p>
+            <a:pPr marL="342900" indent="-342900">
+              <a:buAutoNum type="arabicPeriod"/>
+            </a:pPr>
+            <a:r>
+              <a:rPr lang="en-US" dirty="0"/>
+              <a:t>Go to Android Studio </a:t>
+            </a:r>
+          </a:p>
+          <a:p>
+            <a:pPr marL="342900" indent="-342900">
+              <a:buAutoNum type="arabicPeriod"/>
+            </a:pPr>
+            <a:r>
+              <a:rPr lang="en-US" dirty="0"/>
+              <a:t>Go to Tools / AVD Manager</a:t>
+            </a:r>
+          </a:p>
+          <a:p>
+            <a:pPr marL="342900" indent="-342900">
+              <a:buAutoNum type="arabicPeriod"/>
+            </a:pPr>
+            <a:r>
+              <a:rPr lang="en-US" dirty="0"/>
+              <a:t>Select 80x86 and click on Download</a:t>
+            </a:r>
+          </a:p>
+          <a:p>
+            <a:pPr marL="342900" indent="-342900">
+              <a:buAutoNum type="arabicPeriod"/>
+            </a:pPr>
+            <a:r>
+              <a:rPr lang="en-US" dirty="0"/>
+              <a:t>The system image used by this AVD will now be downloaded, if it wasn’t downloaded before</a:t>
+            </a:r>
+          </a:p>
+        </p:txBody>
+      </p:sp>
       <p:pic>
         <p:nvPicPr>
-          <p:cNvPr id="8" name="Picture 7">
-            <a:extLst>
-              <a:ext uri="{FF2B5EF4-FFF2-40B4-BE49-F238E27FC236}">
-                <a16:creationId xmlns:a16="http://schemas.microsoft.com/office/drawing/2014/main" id="{CAD41869-FF0E-0D4C-A034-D361C1802996}"/>
+          <p:cNvPr id="5" name="Picture 4">
+            <a:extLst>
+              <a:ext uri="{FF2B5EF4-FFF2-40B4-BE49-F238E27FC236}">
+                <a16:creationId xmlns:a16="http://schemas.microsoft.com/office/drawing/2014/main" id="{D693E95F-ADEE-7549-B7C7-67C99F1C5581}"/>
               </a:ext>
             </a:extLst>
           </p:cNvPr>
@@ -3815,143 +3754,8 @@
         </p:blipFill>
         <p:spPr>
           <a:xfrm>
-            <a:off x="5243376" y="3397586"/>
-            <a:ext cx="6845077" cy="541351"/>
-          </a:xfrm>
-          <a:prstGeom prst="rect">
-            <a:avLst/>
-          </a:prstGeom>
-        </p:spPr>
-      </p:pic>
-      <p:sp>
-        <p:nvSpPr>
-          <p:cNvPr id="9" name="TextBox 8">
-            <a:extLst>
-              <a:ext uri="{FF2B5EF4-FFF2-40B4-BE49-F238E27FC236}">
-                <a16:creationId xmlns:a16="http://schemas.microsoft.com/office/drawing/2014/main" id="{F4E9BC54-E338-6E4E-9FC7-8ECA29692963}"/>
-              </a:ext>
-            </a:extLst>
-          </p:cNvPr>
-          <p:cNvSpPr txBox="1"/>
-          <p:nvPr/>
-        </p:nvSpPr>
-        <p:spPr>
-          <a:xfrm>
-            <a:off x="661408" y="4699289"/>
-            <a:ext cx="7091300" cy="646331"/>
-          </a:xfrm>
-          <a:prstGeom prst="rect">
-            <a:avLst/>
-          </a:prstGeom>
-          <a:noFill/>
-        </p:spPr>
-        <p:txBody>
-          <a:bodyPr wrap="none" rtlCol="0">
-            <a:spAutoFit/>
-          </a:bodyPr>
-          <a:lstStyle/>
-          <a:p>
-            <a:r>
-              <a:rPr lang="en-SG" b="1" dirty="0"/>
-              <a:t>export ANDROID_SDK_ROOT=/Users/&lt;Username&gt;/Library/Android/</a:t>
-            </a:r>
-            <a:r>
-              <a:rPr lang="en-SG" b="1" dirty="0" err="1"/>
-              <a:t>sdk</a:t>
-            </a:r>
-            <a:r>
-              <a:rPr lang="en-SG" b="1" dirty="0"/>
-              <a:t> </a:t>
-            </a:r>
-          </a:p>
-          <a:p>
-            <a:endParaRPr lang="en-US" b="1" dirty="0"/>
-          </a:p>
-        </p:txBody>
-      </p:sp>
-      <p:sp>
-        <p:nvSpPr>
-          <p:cNvPr id="10" name="TextBox 9">
-            <a:extLst>
-              <a:ext uri="{FF2B5EF4-FFF2-40B4-BE49-F238E27FC236}">
-                <a16:creationId xmlns:a16="http://schemas.microsoft.com/office/drawing/2014/main" id="{E376243C-0889-6944-A9DC-7BB210D3159D}"/>
-              </a:ext>
-            </a:extLst>
-          </p:cNvPr>
-          <p:cNvSpPr txBox="1"/>
-          <p:nvPr/>
-        </p:nvSpPr>
-        <p:spPr>
-          <a:xfrm>
-            <a:off x="666206" y="5603966"/>
-            <a:ext cx="5712846" cy="923330"/>
-          </a:xfrm>
-          <a:prstGeom prst="rect">
-            <a:avLst/>
-          </a:prstGeom>
-          <a:noFill/>
-        </p:spPr>
-        <p:txBody>
-          <a:bodyPr wrap="none" rtlCol="0">
-            <a:spAutoFit/>
-          </a:bodyPr>
-          <a:lstStyle/>
-          <a:p>
-            <a:r>
-              <a:rPr lang="en-US" dirty="0"/>
-              <a:t>$ emulator -</a:t>
-            </a:r>
-            <a:r>
-              <a:rPr lang="en-US" dirty="0" err="1"/>
-              <a:t>avd</a:t>
-            </a:r>
-            <a:r>
-              <a:rPr lang="en-US" dirty="0"/>
-              <a:t> 80x86 -writable-system -</a:t>
-            </a:r>
-            <a:r>
-              <a:rPr lang="en-US" dirty="0" err="1"/>
-              <a:t>selinux</a:t>
-            </a:r>
-            <a:r>
-              <a:rPr lang="en-US" dirty="0"/>
-              <a:t> permissive</a:t>
-            </a:r>
-          </a:p>
-          <a:p>
-            <a:endParaRPr lang="en-US" dirty="0"/>
-          </a:p>
-          <a:p>
-            <a:r>
-              <a:rPr lang="en-US" dirty="0"/>
-              <a:t>We need to start it with both flags!</a:t>
-            </a:r>
-          </a:p>
-        </p:txBody>
-      </p:sp>
-      <p:pic>
-        <p:nvPicPr>
-          <p:cNvPr id="11" name="Picture 10">
-            <a:extLst>
-              <a:ext uri="{FF2B5EF4-FFF2-40B4-BE49-F238E27FC236}">
-                <a16:creationId xmlns:a16="http://schemas.microsoft.com/office/drawing/2014/main" id="{729B975A-F67A-CE41-AA49-16D71622623C}"/>
-              </a:ext>
-            </a:extLst>
-          </p:cNvPr>
-          <p:cNvPicPr>
-            <a:picLocks noChangeAspect="1"/>
-          </p:cNvPicPr>
-          <p:nvPr/>
-        </p:nvPicPr>
-        <p:blipFill rotWithShape="1">
-          <a:blip r:embed="rId4"/>
-          <a:srcRect b="43026"/>
-          <a:stretch/>
-        </p:blipFill>
-        <p:spPr>
-          <a:xfrm>
-            <a:off x="6379052" y="5157723"/>
-            <a:ext cx="6483582" cy="1566927"/>
+            <a:off x="473375" y="4327072"/>
+            <a:ext cx="4876800" cy="1600200"/>
           </a:xfrm>
           <a:prstGeom prst="rect">
             <a:avLst/>
@@ -3961,7 +3765,7 @@
     </p:spTree>
     <p:extLst>
       <p:ext uri="{BB962C8B-B14F-4D97-AF65-F5344CB8AC3E}">
-        <p14:creationId xmlns:p14="http://schemas.microsoft.com/office/powerpoint/2010/main" val="256750888"/>
+        <p14:creationId xmlns:p14="http://schemas.microsoft.com/office/powerpoint/2010/main" val="3261444337"/>
       </p:ext>
     </p:extLst>
   </p:cSld>
@@ -4004,192 +3808,168 @@
             <p:ph type="title"/>
           </p:nvPr>
         </p:nvSpPr>
-        <p:spPr>
-          <a:xfrm>
-            <a:off x="838200" y="365125"/>
-            <a:ext cx="10866120" cy="1325563"/>
-          </a:xfrm>
-        </p:spPr>
-        <p:txBody>
-          <a:bodyPr>
-            <a:normAutofit/>
+        <p:spPr/>
+        <p:txBody>
+          <a:bodyPr/>
+          <a:lstStyle/>
+          <a:p>
+            <a:r>
+              <a:rPr lang="en-US" dirty="0"/>
+              <a:t>Create AVD (Android Virtual Device)</a:t>
+            </a:r>
+          </a:p>
+        </p:txBody>
+      </p:sp>
+      <p:sp>
+        <p:nvSpPr>
+          <p:cNvPr id="3" name="TextBox 2">
+            <a:extLst>
+              <a:ext uri="{FF2B5EF4-FFF2-40B4-BE49-F238E27FC236}">
+                <a16:creationId xmlns:a16="http://schemas.microsoft.com/office/drawing/2014/main" id="{EEF5B2E1-FE6E-A44E-8F22-61F4DD0D7F88}"/>
+              </a:ext>
+            </a:extLst>
+          </p:cNvPr>
+          <p:cNvSpPr txBox="1"/>
+          <p:nvPr/>
+        </p:nvSpPr>
+        <p:spPr>
+          <a:xfrm>
+            <a:off x="307793" y="1595739"/>
+            <a:ext cx="5074104" cy="3970318"/>
+          </a:xfrm>
+          <a:prstGeom prst="rect">
+            <a:avLst/>
+          </a:prstGeom>
+          <a:noFill/>
+        </p:spPr>
+        <p:txBody>
+          <a:bodyPr wrap="square" rtlCol="0">
+            <a:spAutoFit/>
           </a:bodyPr>
           <a:lstStyle/>
           <a:p>
             <a:r>
-              <a:rPr lang="en-US" sz="3600"/>
-              <a:t>Check if adb is installed and if the emulator can be found </a:t>
-            </a:r>
-          </a:p>
-        </p:txBody>
-      </p:sp>
-      <p:sp>
-        <p:nvSpPr>
-          <p:cNvPr id="3" name="Content Placeholder 2">
-            <a:extLst>
-              <a:ext uri="{FF2B5EF4-FFF2-40B4-BE49-F238E27FC236}">
-                <a16:creationId xmlns:a16="http://schemas.microsoft.com/office/drawing/2014/main" id="{5D98E177-C354-D542-A14E-E86EEC9F17A0}"/>
-              </a:ext>
-            </a:extLst>
-          </p:cNvPr>
-          <p:cNvSpPr>
-            <a:spLocks noGrp="1"/>
-          </p:cNvSpPr>
-          <p:nvPr>
-            <p:ph idx="1"/>
-          </p:nvPr>
-        </p:nvSpPr>
-        <p:spPr/>
-        <p:txBody>
-          <a:bodyPr>
-            <a:normAutofit/>
-          </a:bodyPr>
-          <a:lstStyle/>
+              <a:rPr lang="en-US" b="1" dirty="0"/>
+              <a:t>Next we start our AVD</a:t>
+            </a:r>
+          </a:p>
           <a:p>
             <a:endParaRPr lang="en-US" dirty="0"/>
           </a:p>
           <a:p>
+            <a:pPr marL="342900" indent="-342900">
+              <a:buAutoNum type="arabicPeriod"/>
+            </a:pPr>
+            <a:r>
+              <a:rPr lang="en-US" dirty="0"/>
+              <a:t>Go to the Android SDK directory and go tools. There you will find the ‘emulator’ command. It’s located in: /Users/</a:t>
+            </a:r>
+            <a:r>
+              <a:rPr lang="en-US" dirty="0" err="1"/>
+              <a:t>sven</a:t>
+            </a:r>
+            <a:r>
+              <a:rPr lang="en-US" dirty="0"/>
+              <a:t>/Library/Android/</a:t>
+            </a:r>
+            <a:r>
+              <a:rPr lang="en-US" dirty="0" err="1"/>
+              <a:t>sdk</a:t>
+            </a:r>
+            <a:r>
+              <a:rPr lang="en-US" dirty="0"/>
+              <a:t>/tools (macOS) </a:t>
+            </a:r>
+          </a:p>
+          <a:p>
+            <a:pPr marL="342900" indent="-342900">
+              <a:buAutoNum type="arabicPeriod"/>
+            </a:pPr>
             <a:endParaRPr lang="en-US" dirty="0"/>
           </a:p>
           <a:p>
+            <a:pPr marL="342900" indent="-342900">
+              <a:buAutoNum type="arabicPeriod"/>
+            </a:pPr>
+            <a:r>
+              <a:rPr lang="en-US" dirty="0"/>
+              <a:t>Let’s start our emulator with two custom flags</a:t>
+            </a:r>
+          </a:p>
+          <a:p>
+            <a:pPr marL="342900" indent="-342900">
+              <a:buAutoNum type="arabicPeriod"/>
+            </a:pPr>
             <a:endParaRPr lang="en-US" dirty="0"/>
           </a:p>
           <a:p>
-            <a:pPr marL="0" indent="0">
-              <a:buNone/>
+            <a:pPr marL="342900" indent="-342900">
+              <a:buAutoNum type="arabicPeriod"/>
             </a:pPr>
             <a:r>
               <a:rPr lang="en-US" dirty="0"/>
-              <a:t>Note: you can find </a:t>
-            </a:r>
-            <a:r>
-              <a:rPr lang="en-US" dirty="0" err="1"/>
-              <a:t>adb</a:t>
-            </a:r>
+              <a:t>In case you get an error like this, set the ANDROID_SDK_ROOT</a:t>
+            </a:r>
+          </a:p>
+          <a:p>
+            <a:pPr marL="342900" indent="-342900">
+              <a:buAutoNum type="arabicPeriod"/>
+            </a:pPr>
+            <a:endParaRPr lang="en-US" dirty="0"/>
+          </a:p>
+          <a:p>
+            <a:pPr marL="342900" indent="-342900">
+              <a:buAutoNum type="arabicPeriod"/>
+            </a:pPr>
+            <a:endParaRPr lang="en-US" dirty="0"/>
+          </a:p>
+          <a:p>
+            <a:pPr marL="342900" indent="-342900">
+              <a:buAutoNum type="arabicPeriod"/>
+            </a:pPr>
             <a:r>
               <a:rPr lang="en-US" dirty="0"/>
-              <a:t> in your $ANDROID_HOME/tools (e.g. on Mac OS X that can be </a:t>
-            </a:r>
-            <a:r>
-              <a:rPr lang="nl-NL" dirty="0"/>
-              <a:t>/Users/&lt;username&gt;/Library/Android/</a:t>
-            </a:r>
-            <a:r>
-              <a:rPr lang="nl-NL" dirty="0" err="1"/>
-              <a:t>sdk</a:t>
-            </a:r>
-            <a:r>
-              <a:rPr lang="nl-NL" dirty="0"/>
-              <a:t>/tools). </a:t>
-            </a:r>
-            <a:r>
-              <a:rPr lang="nl-NL" dirty="0" err="1"/>
-              <a:t>Add</a:t>
-            </a:r>
-            <a:r>
-              <a:rPr lang="nl-NL" dirty="0"/>
-              <a:t> </a:t>
-            </a:r>
-            <a:r>
-              <a:rPr lang="nl-NL" dirty="0" err="1"/>
-              <a:t>it</a:t>
-            </a:r>
-            <a:r>
-              <a:rPr lang="nl-NL" dirty="0"/>
-              <a:t> </a:t>
-            </a:r>
-            <a:r>
-              <a:rPr lang="nl-NL" dirty="0" err="1"/>
-              <a:t>to</a:t>
-            </a:r>
-            <a:r>
-              <a:rPr lang="nl-NL" dirty="0"/>
-              <a:t> </a:t>
-            </a:r>
-            <a:r>
-              <a:rPr lang="nl-NL" dirty="0" err="1"/>
-              <a:t>your</a:t>
-            </a:r>
-            <a:r>
-              <a:rPr lang="nl-NL" dirty="0"/>
-              <a:t> PATH </a:t>
-            </a:r>
-            <a:r>
-              <a:rPr lang="nl-NL" dirty="0" err="1"/>
-              <a:t>to</a:t>
-            </a:r>
-            <a:r>
-              <a:rPr lang="nl-NL" dirty="0"/>
-              <a:t> make </a:t>
-            </a:r>
-            <a:r>
-              <a:rPr lang="nl-NL" dirty="0" err="1"/>
-              <a:t>it</a:t>
-            </a:r>
-            <a:r>
-              <a:rPr lang="nl-NL" dirty="0"/>
-              <a:t> </a:t>
-            </a:r>
-            <a:r>
-              <a:rPr lang="nl-NL" dirty="0" err="1"/>
-              <a:t>reachable</a:t>
-            </a:r>
-            <a:r>
-              <a:rPr lang="nl-NL" dirty="0"/>
-              <a:t> </a:t>
-            </a:r>
-            <a:r>
-              <a:rPr lang="nl-NL" dirty="0" err="1"/>
-              <a:t>everywhere</a:t>
-            </a:r>
-            <a:r>
-              <a:rPr lang="nl-NL" dirty="0"/>
-              <a:t>.</a:t>
-            </a:r>
-          </a:p>
-          <a:p>
-            <a:pPr marL="0" indent="0">
-              <a:buNone/>
-            </a:pPr>
-            <a:endParaRPr lang="en-US" dirty="0"/>
-          </a:p>
-          <a:p>
-            <a:pPr marL="0" indent="0">
-              <a:buNone/>
-            </a:pPr>
-            <a:r>
-              <a:rPr lang="en-US" dirty="0"/>
-              <a:t>Still in trouble? Follow </a:t>
-            </a:r>
-            <a:r>
-              <a:rPr lang="en-US"/>
-              <a:t>the instructions here:</a:t>
-            </a:r>
-            <a:endParaRPr lang="en-US" dirty="0"/>
-          </a:p>
-          <a:p>
-            <a:pPr marL="0" indent="0">
-              <a:buNone/>
-            </a:pPr>
-            <a:r>
-              <a:rPr lang="en-US" dirty="0">
-                <a:hlinkClick r:id="rId2"/>
-              </a:rPr>
-              <a:t>https://www.xda-developers.com/install-adb-windows-macos-linux/</a:t>
-            </a:r>
-            <a:r>
-              <a:rPr lang="en-US" dirty="0"/>
-              <a:t> </a:t>
+              <a:t>Let’s start the AVD</a:t>
             </a:r>
           </a:p>
         </p:txBody>
       </p:sp>
       <p:pic>
         <p:nvPicPr>
-          <p:cNvPr id="4" name="Picture 3">
-            <a:extLst>
-              <a:ext uri="{FF2B5EF4-FFF2-40B4-BE49-F238E27FC236}">
-                <a16:creationId xmlns:a16="http://schemas.microsoft.com/office/drawing/2014/main" id="{8A92F754-361C-0D42-8F52-3F39283354D5}"/>
+          <p:cNvPr id="6" name="Picture 5">
+            <a:extLst>
+              <a:ext uri="{FF2B5EF4-FFF2-40B4-BE49-F238E27FC236}">
+                <a16:creationId xmlns:a16="http://schemas.microsoft.com/office/drawing/2014/main" id="{977544D5-6DA7-3247-89BB-8C7DCC6EAF63}"/>
+              </a:ext>
+            </a:extLst>
+          </p:cNvPr>
+          <p:cNvPicPr>
+            <a:picLocks noChangeAspect="1"/>
+          </p:cNvPicPr>
+          <p:nvPr/>
+        </p:nvPicPr>
+        <p:blipFill>
+          <a:blip r:embed="rId2"/>
+          <a:stretch>
+            <a:fillRect/>
+          </a:stretch>
+        </p:blipFill>
+        <p:spPr>
+          <a:xfrm>
+            <a:off x="5243376" y="2305401"/>
+            <a:ext cx="7434984" cy="397148"/>
+          </a:xfrm>
+          <a:prstGeom prst="rect">
+            <a:avLst/>
+          </a:prstGeom>
+        </p:spPr>
+      </p:pic>
+      <p:pic>
+        <p:nvPicPr>
+          <p:cNvPr id="8" name="Picture 7">
+            <a:extLst>
+              <a:ext uri="{FF2B5EF4-FFF2-40B4-BE49-F238E27FC236}">
+                <a16:creationId xmlns:a16="http://schemas.microsoft.com/office/drawing/2014/main" id="{CAD41869-FF0E-0D4C-A034-D361C1802996}"/>
               </a:ext>
             </a:extLst>
           </p:cNvPr>
@@ -4206,8 +3986,143 @@
         </p:blipFill>
         <p:spPr>
           <a:xfrm>
-            <a:off x="3977790" y="1825625"/>
-            <a:ext cx="3784600" cy="876300"/>
+            <a:off x="5243376" y="3397586"/>
+            <a:ext cx="6845077" cy="541351"/>
+          </a:xfrm>
+          <a:prstGeom prst="rect">
+            <a:avLst/>
+          </a:prstGeom>
+        </p:spPr>
+      </p:pic>
+      <p:sp>
+        <p:nvSpPr>
+          <p:cNvPr id="9" name="TextBox 8">
+            <a:extLst>
+              <a:ext uri="{FF2B5EF4-FFF2-40B4-BE49-F238E27FC236}">
+                <a16:creationId xmlns:a16="http://schemas.microsoft.com/office/drawing/2014/main" id="{F4E9BC54-E338-6E4E-9FC7-8ECA29692963}"/>
+              </a:ext>
+            </a:extLst>
+          </p:cNvPr>
+          <p:cNvSpPr txBox="1"/>
+          <p:nvPr/>
+        </p:nvSpPr>
+        <p:spPr>
+          <a:xfrm>
+            <a:off x="661408" y="4699289"/>
+            <a:ext cx="7091300" cy="646331"/>
+          </a:xfrm>
+          <a:prstGeom prst="rect">
+            <a:avLst/>
+          </a:prstGeom>
+          <a:noFill/>
+        </p:spPr>
+        <p:txBody>
+          <a:bodyPr wrap="none" rtlCol="0">
+            <a:spAutoFit/>
+          </a:bodyPr>
+          <a:lstStyle/>
+          <a:p>
+            <a:r>
+              <a:rPr lang="en-SG" b="1" dirty="0"/>
+              <a:t>export ANDROID_SDK_ROOT=/Users/&lt;Username&gt;/Library/Android/</a:t>
+            </a:r>
+            <a:r>
+              <a:rPr lang="en-SG" b="1" dirty="0" err="1"/>
+              <a:t>sdk</a:t>
+            </a:r>
+            <a:r>
+              <a:rPr lang="en-SG" b="1" dirty="0"/>
+              <a:t> </a:t>
+            </a:r>
+          </a:p>
+          <a:p>
+            <a:endParaRPr lang="en-US" b="1" dirty="0"/>
+          </a:p>
+        </p:txBody>
+      </p:sp>
+      <p:sp>
+        <p:nvSpPr>
+          <p:cNvPr id="10" name="TextBox 9">
+            <a:extLst>
+              <a:ext uri="{FF2B5EF4-FFF2-40B4-BE49-F238E27FC236}">
+                <a16:creationId xmlns:a16="http://schemas.microsoft.com/office/drawing/2014/main" id="{E376243C-0889-6944-A9DC-7BB210D3159D}"/>
+              </a:ext>
+            </a:extLst>
+          </p:cNvPr>
+          <p:cNvSpPr txBox="1"/>
+          <p:nvPr/>
+        </p:nvSpPr>
+        <p:spPr>
+          <a:xfrm>
+            <a:off x="666206" y="5603966"/>
+            <a:ext cx="5712846" cy="923330"/>
+          </a:xfrm>
+          <a:prstGeom prst="rect">
+            <a:avLst/>
+          </a:prstGeom>
+          <a:noFill/>
+        </p:spPr>
+        <p:txBody>
+          <a:bodyPr wrap="none" rtlCol="0">
+            <a:spAutoFit/>
+          </a:bodyPr>
+          <a:lstStyle/>
+          <a:p>
+            <a:r>
+              <a:rPr lang="en-US" dirty="0"/>
+              <a:t>$ emulator -</a:t>
+            </a:r>
+            <a:r>
+              <a:rPr lang="en-US" dirty="0" err="1"/>
+              <a:t>avd</a:t>
+            </a:r>
+            <a:r>
+              <a:rPr lang="en-US" dirty="0"/>
+              <a:t> 80x86 -writable-system -</a:t>
+            </a:r>
+            <a:r>
+              <a:rPr lang="en-US" dirty="0" err="1"/>
+              <a:t>selinux</a:t>
+            </a:r>
+            <a:r>
+              <a:rPr lang="en-US" dirty="0"/>
+              <a:t> permissive</a:t>
+            </a:r>
+          </a:p>
+          <a:p>
+            <a:endParaRPr lang="en-US" dirty="0"/>
+          </a:p>
+          <a:p>
+            <a:r>
+              <a:rPr lang="en-US" dirty="0"/>
+              <a:t>We need to start it with both flags!</a:t>
+            </a:r>
+          </a:p>
+        </p:txBody>
+      </p:sp>
+      <p:pic>
+        <p:nvPicPr>
+          <p:cNvPr id="11" name="Picture 10">
+            <a:extLst>
+              <a:ext uri="{FF2B5EF4-FFF2-40B4-BE49-F238E27FC236}">
+                <a16:creationId xmlns:a16="http://schemas.microsoft.com/office/drawing/2014/main" id="{729B975A-F67A-CE41-AA49-16D71622623C}"/>
+              </a:ext>
+            </a:extLst>
+          </p:cNvPr>
+          <p:cNvPicPr>
+            <a:picLocks noChangeAspect="1"/>
+          </p:cNvPicPr>
+          <p:nvPr/>
+        </p:nvPicPr>
+        <p:blipFill rotWithShape="1">
+          <a:blip r:embed="rId4"/>
+          <a:srcRect b="43026"/>
+          <a:stretch/>
+        </p:blipFill>
+        <p:spPr>
+          <a:xfrm>
+            <a:off x="6379052" y="5157723"/>
+            <a:ext cx="6483582" cy="1566927"/>
           </a:xfrm>
           <a:prstGeom prst="rect">
             <a:avLst/>
@@ -4217,7 +4132,7 @@
     </p:spTree>
     <p:extLst>
       <p:ext uri="{BB962C8B-B14F-4D97-AF65-F5344CB8AC3E}">
-        <p14:creationId xmlns:p14="http://schemas.microsoft.com/office/powerpoint/2010/main" val="1197823365"/>
+        <p14:creationId xmlns:p14="http://schemas.microsoft.com/office/powerpoint/2010/main" val="256750888"/>
       </p:ext>
     </p:extLst>
   </p:cSld>
@@ -4262,7 +4177,7 @@
         </p:nvSpPr>
         <p:spPr>
           <a:xfrm>
-            <a:off x="838200" y="85427"/>
+            <a:off x="838200" y="365125"/>
             <a:ext cx="10866120" cy="1325563"/>
           </a:xfrm>
         </p:spPr>
@@ -4273,8 +4188,8 @@
           <a:lstStyle/>
           <a:p>
             <a:r>
-              <a:rPr lang="en-US" sz="3600" dirty="0"/>
-              <a:t>Check the root access on the emulator </a:t>
+              <a:rPr lang="en-US" sz="3600"/>
+              <a:t>Check if adb is installed and if the emulator can be found </a:t>
             </a:r>
           </a:p>
         </p:txBody>
@@ -4297,13 +4212,146 @@
         </p:nvSpPr>
         <p:spPr/>
         <p:txBody>
-          <a:bodyPr/>
-          <a:lstStyle/>
-          <a:p>
-            <a:endParaRPr lang="en-US"/>
-          </a:p>
-          <a:p>
-            <a:endParaRPr lang="en-US"/>
+          <a:bodyPr>
+            <a:normAutofit/>
+          </a:bodyPr>
+          <a:lstStyle/>
+          <a:p>
+            <a:endParaRPr lang="en-US" dirty="0"/>
+          </a:p>
+          <a:p>
+            <a:endParaRPr lang="en-US" dirty="0"/>
+          </a:p>
+          <a:p>
+            <a:endParaRPr lang="en-US" dirty="0"/>
+          </a:p>
+          <a:p>
+            <a:pPr marL="0" indent="0">
+              <a:buNone/>
+            </a:pPr>
+            <a:r>
+              <a:rPr lang="en-US" dirty="0"/>
+              <a:t>Note: you can find </a:t>
+            </a:r>
+            <a:r>
+              <a:rPr lang="en-US" dirty="0" err="1"/>
+              <a:t>adb</a:t>
+            </a:r>
+            <a:r>
+              <a:rPr lang="en-US" dirty="0"/>
+              <a:t> in your $ANDROID_HOME/tools (e.g. on Mac OS X that can be </a:t>
+            </a:r>
+            <a:r>
+              <a:rPr lang="nl-NL" dirty="0"/>
+              <a:t>/Users/&lt;username&gt;/Library/Android/</a:t>
+            </a:r>
+            <a:r>
+              <a:rPr lang="nl-NL" dirty="0" err="1"/>
+              <a:t>sdk</a:t>
+            </a:r>
+            <a:r>
+              <a:rPr lang="nl-NL" dirty="0"/>
+              <a:t>/tools). </a:t>
+            </a:r>
+            <a:r>
+              <a:rPr lang="nl-NL" dirty="0" err="1"/>
+              <a:t>Add</a:t>
+            </a:r>
+            <a:r>
+              <a:rPr lang="nl-NL" dirty="0"/>
+              <a:t> </a:t>
+            </a:r>
+            <a:r>
+              <a:rPr lang="nl-NL" dirty="0" err="1"/>
+              <a:t>it</a:t>
+            </a:r>
+            <a:r>
+              <a:rPr lang="nl-NL" dirty="0"/>
+              <a:t> </a:t>
+            </a:r>
+            <a:r>
+              <a:rPr lang="nl-NL" dirty="0" err="1"/>
+              <a:t>to</a:t>
+            </a:r>
+            <a:r>
+              <a:rPr lang="nl-NL" dirty="0"/>
+              <a:t> </a:t>
+            </a:r>
+            <a:r>
+              <a:rPr lang="nl-NL" dirty="0" err="1"/>
+              <a:t>your</a:t>
+            </a:r>
+            <a:r>
+              <a:rPr lang="nl-NL" dirty="0"/>
+              <a:t> PATH </a:t>
+            </a:r>
+            <a:r>
+              <a:rPr lang="nl-NL" dirty="0" err="1"/>
+              <a:t>to</a:t>
+            </a:r>
+            <a:r>
+              <a:rPr lang="nl-NL" dirty="0"/>
+              <a:t> make </a:t>
+            </a:r>
+            <a:r>
+              <a:rPr lang="nl-NL" dirty="0" err="1"/>
+              <a:t>it</a:t>
+            </a:r>
+            <a:r>
+              <a:rPr lang="nl-NL" dirty="0"/>
+              <a:t> </a:t>
+            </a:r>
+            <a:r>
+              <a:rPr lang="nl-NL" dirty="0" err="1"/>
+              <a:t>reachable</a:t>
+            </a:r>
+            <a:r>
+              <a:rPr lang="nl-NL" dirty="0"/>
+              <a:t> </a:t>
+            </a:r>
+            <a:r>
+              <a:rPr lang="nl-NL" dirty="0" err="1"/>
+              <a:t>everywhere</a:t>
+            </a:r>
+            <a:r>
+              <a:rPr lang="nl-NL" dirty="0"/>
+              <a:t>.</a:t>
+            </a:r>
+          </a:p>
+          <a:p>
+            <a:pPr marL="0" indent="0">
+              <a:buNone/>
+            </a:pPr>
+            <a:endParaRPr lang="en-US" dirty="0"/>
+          </a:p>
+          <a:p>
+            <a:pPr marL="0" indent="0">
+              <a:buNone/>
+            </a:pPr>
+            <a:r>
+              <a:rPr lang="en-US" dirty="0"/>
+              <a:t>Still in trouble? Follow </a:t>
+            </a:r>
+            <a:r>
+              <a:rPr lang="en-US"/>
+              <a:t>the instructions here:</a:t>
+            </a:r>
+            <a:endParaRPr lang="en-US" dirty="0"/>
+          </a:p>
+          <a:p>
+            <a:pPr marL="0" indent="0">
+              <a:buNone/>
+            </a:pPr>
+            <a:r>
+              <a:rPr lang="en-US" dirty="0">
+                <a:hlinkClick r:id="rId2"/>
+              </a:rPr>
+              <a:t>https://www.xda-developers.com/install-adb-windows-macos-linux/</a:t>
+            </a:r>
+            <a:r>
+              <a:rPr lang="en-US" dirty="0"/>
+              <a:t> </a:t>
+            </a:r>
           </a:p>
         </p:txBody>
       </p:sp>
@@ -4312,7 +4360,7 @@
           <p:cNvPr id="4" name="Picture 3">
             <a:extLst>
               <a:ext uri="{FF2B5EF4-FFF2-40B4-BE49-F238E27FC236}">
-                <a16:creationId xmlns:a16="http://schemas.microsoft.com/office/drawing/2014/main" id="{120BA053-73BF-C24F-92C0-D6D51597FE90}"/>
+                <a16:creationId xmlns:a16="http://schemas.microsoft.com/office/drawing/2014/main" id="{8A92F754-361C-0D42-8F52-3F39283354D5}"/>
               </a:ext>
             </a:extLst>
           </p:cNvPr>
@@ -4322,15 +4370,15 @@
           <p:nvPr/>
         </p:nvPicPr>
         <p:blipFill>
-          <a:blip r:embed="rId2"/>
+          <a:blip r:embed="rId3"/>
           <a:stretch>
             <a:fillRect/>
           </a:stretch>
         </p:blipFill>
         <p:spPr>
           <a:xfrm>
-            <a:off x="2608132" y="2200538"/>
-            <a:ext cx="6502400" cy="3403600"/>
+            <a:off x="3977790" y="1825625"/>
+            <a:ext cx="3784600" cy="876300"/>
           </a:xfrm>
           <a:prstGeom prst="rect">
             <a:avLst/>
@@ -4340,7 +4388,7 @@
     </p:spTree>
     <p:extLst>
       <p:ext uri="{BB962C8B-B14F-4D97-AF65-F5344CB8AC3E}">
-        <p14:creationId xmlns:p14="http://schemas.microsoft.com/office/powerpoint/2010/main" val="1084918039"/>
+        <p14:creationId xmlns:p14="http://schemas.microsoft.com/office/powerpoint/2010/main" val="1197823365"/>
       </p:ext>
     </p:extLst>
   </p:cSld>
@@ -4396,8 +4444,8 @@
           <a:lstStyle/>
           <a:p>
             <a:r>
-              <a:rPr lang="en-US" sz="3600"/>
-              <a:t>Start Burp Suite and create a temporary project </a:t>
+              <a:rPr lang="en-US" sz="3600" dirty="0"/>
+              <a:t>Check the root access on the emulator </a:t>
             </a:r>
           </a:p>
         </p:txBody>
@@ -4432,10 +4480,10 @@
       </p:sp>
       <p:pic>
         <p:nvPicPr>
-          <p:cNvPr id="5" name="Picture 4">
-            <a:extLst>
-              <a:ext uri="{FF2B5EF4-FFF2-40B4-BE49-F238E27FC236}">
-                <a16:creationId xmlns:a16="http://schemas.microsoft.com/office/drawing/2014/main" id="{AE7770F8-CE27-4646-AB68-DDD884B310ED}"/>
+          <p:cNvPr id="4" name="Picture 3">
+            <a:extLst>
+              <a:ext uri="{FF2B5EF4-FFF2-40B4-BE49-F238E27FC236}">
+                <a16:creationId xmlns:a16="http://schemas.microsoft.com/office/drawing/2014/main" id="{120BA053-73BF-C24F-92C0-D6D51597FE90}"/>
               </a:ext>
             </a:extLst>
           </p:cNvPr>
@@ -4452,8 +4500,8 @@
         </p:blipFill>
         <p:spPr>
           <a:xfrm>
-            <a:off x="2138867" y="1447347"/>
-            <a:ext cx="8264786" cy="5107893"/>
+            <a:off x="2608132" y="2200538"/>
+            <a:ext cx="6502400" cy="3403600"/>
           </a:xfrm>
           <a:prstGeom prst="rect">
             <a:avLst/>
@@ -4463,7 +4511,7 @@
     </p:spTree>
     <p:extLst>
       <p:ext uri="{BB962C8B-B14F-4D97-AF65-F5344CB8AC3E}">
-        <p14:creationId xmlns:p14="http://schemas.microsoft.com/office/powerpoint/2010/main" val="2060106848"/>
+        <p14:creationId xmlns:p14="http://schemas.microsoft.com/office/powerpoint/2010/main" val="1084918039"/>
       </p:ext>
     </p:extLst>
   </p:cSld>
@@ -4508,8 +4556,8 @@
         </p:nvSpPr>
         <p:spPr>
           <a:xfrm>
-            <a:off x="838199" y="85427"/>
-            <a:ext cx="11210365" cy="1325563"/>
+            <a:off x="838200" y="85427"/>
+            <a:ext cx="10866120" cy="1325563"/>
           </a:xfrm>
         </p:spPr>
         <p:txBody>
@@ -4520,7 +4568,7 @@
           <a:p>
             <a:r>
               <a:rPr lang="en-US" sz="3600"/>
-              <a:t>Check if the Proxy Server from Burp is running on port 8080</a:t>
+              <a:t>Start Burp Suite and create a temporary project </a:t>
             </a:r>
           </a:p>
         </p:txBody>
@@ -4555,10 +4603,10 @@
       </p:sp>
       <p:pic>
         <p:nvPicPr>
-          <p:cNvPr id="4" name="Picture 3">
-            <a:extLst>
-              <a:ext uri="{FF2B5EF4-FFF2-40B4-BE49-F238E27FC236}">
-                <a16:creationId xmlns:a16="http://schemas.microsoft.com/office/drawing/2014/main" id="{828C81AE-2ED0-1A44-B422-02F4743FF367}"/>
+          <p:cNvPr id="5" name="Picture 4">
+            <a:extLst>
+              <a:ext uri="{FF2B5EF4-FFF2-40B4-BE49-F238E27FC236}">
+                <a16:creationId xmlns:a16="http://schemas.microsoft.com/office/drawing/2014/main" id="{AE7770F8-CE27-4646-AB68-DDD884B310ED}"/>
               </a:ext>
             </a:extLst>
           </p:cNvPr>
@@ -4575,8 +4623,8 @@
         </p:blipFill>
         <p:spPr>
           <a:xfrm>
-            <a:off x="3695700" y="1708150"/>
-            <a:ext cx="4800600" cy="3441700"/>
+            <a:off x="2138867" y="1447347"/>
+            <a:ext cx="8264786" cy="5107893"/>
           </a:xfrm>
           <a:prstGeom prst="rect">
             <a:avLst/>
@@ -4586,7 +4634,7 @@
     </p:spTree>
     <p:extLst>
       <p:ext uri="{BB962C8B-B14F-4D97-AF65-F5344CB8AC3E}">
-        <p14:creationId xmlns:p14="http://schemas.microsoft.com/office/powerpoint/2010/main" val="192477708"/>
+        <p14:creationId xmlns:p14="http://schemas.microsoft.com/office/powerpoint/2010/main" val="2060106848"/>
       </p:ext>
     </p:extLst>
   </p:cSld>
@@ -4631,8 +4679,8 @@
         </p:nvSpPr>
         <p:spPr>
           <a:xfrm>
-            <a:off x="838200" y="85427"/>
-            <a:ext cx="10866120" cy="1325563"/>
+            <a:off x="838199" y="85427"/>
+            <a:ext cx="11210365" cy="1325563"/>
           </a:xfrm>
         </p:spPr>
         <p:txBody>
@@ -4643,7 +4691,7 @@
           <a:p>
             <a:r>
               <a:rPr lang="en-US" sz="3600"/>
-              <a:t>Configure the AVD to use Burp as Proxy </a:t>
+              <a:t>Check if the Proxy Server from Burp is running on port 8080</a:t>
             </a:r>
           </a:p>
         </p:txBody>
@@ -4681,7 +4729,7 @@
           <p:cNvPr id="4" name="Picture 3">
             <a:extLst>
               <a:ext uri="{FF2B5EF4-FFF2-40B4-BE49-F238E27FC236}">
-                <a16:creationId xmlns:a16="http://schemas.microsoft.com/office/drawing/2014/main" id="{968B3877-D59A-A84F-8393-96F5655C4C79}"/>
+                <a16:creationId xmlns:a16="http://schemas.microsoft.com/office/drawing/2014/main" id="{828C81AE-2ED0-1A44-B422-02F4743FF367}"/>
               </a:ext>
             </a:extLst>
           </p:cNvPr>
@@ -4698,8 +4746,8 @@
         </p:blipFill>
         <p:spPr>
           <a:xfrm>
-            <a:off x="1129553" y="1298307"/>
-            <a:ext cx="9403462" cy="5405973"/>
+            <a:off x="3695700" y="1708150"/>
+            <a:ext cx="4800600" cy="3441700"/>
           </a:xfrm>
           <a:prstGeom prst="rect">
             <a:avLst/>
@@ -4709,7 +4757,7 @@
     </p:spTree>
     <p:extLst>
       <p:ext uri="{BB962C8B-B14F-4D97-AF65-F5344CB8AC3E}">
-        <p14:creationId xmlns:p14="http://schemas.microsoft.com/office/powerpoint/2010/main" val="4024758949"/>
+        <p14:creationId xmlns:p14="http://schemas.microsoft.com/office/powerpoint/2010/main" val="192477708"/>
       </p:ext>
     </p:extLst>
   </p:cSld>
@@ -4738,10 +4786,10 @@
       </p:grpSpPr>
       <p:sp>
         <p:nvSpPr>
-          <p:cNvPr id="2" name="Titel 1">
-            <a:extLst>
-              <a:ext uri="{FF2B5EF4-FFF2-40B4-BE49-F238E27FC236}">
-                <a16:creationId xmlns:a16="http://schemas.microsoft.com/office/drawing/2014/main" id="{0E1A5BE2-2C25-DF4B-A390-A96416A96624}"/>
+          <p:cNvPr id="2" name="Title 1">
+            <a:extLst>
+              <a:ext uri="{FF2B5EF4-FFF2-40B4-BE49-F238E27FC236}">
+                <a16:creationId xmlns:a16="http://schemas.microsoft.com/office/drawing/2014/main" id="{93966762-C3A5-3C4D-A279-EF6ECE00A35F}"/>
               </a:ext>
             </a:extLst>
           </p:cNvPr>
@@ -4752,125 +4800,87 @@
             <p:ph type="title"/>
           </p:nvPr>
         </p:nvSpPr>
+        <p:spPr>
+          <a:xfrm>
+            <a:off x="838200" y="85427"/>
+            <a:ext cx="10866120" cy="1325563"/>
+          </a:xfrm>
+        </p:spPr>
+        <p:txBody>
+          <a:bodyPr>
+            <a:normAutofit/>
+          </a:bodyPr>
+          <a:lstStyle/>
+          <a:p>
+            <a:r>
+              <a:rPr lang="en-US" sz="3600"/>
+              <a:t>Configure the AVD to use Burp as Proxy </a:t>
+            </a:r>
+          </a:p>
+        </p:txBody>
+      </p:sp>
+      <p:sp>
+        <p:nvSpPr>
+          <p:cNvPr id="3" name="Content Placeholder 2">
+            <a:extLst>
+              <a:ext uri="{FF2B5EF4-FFF2-40B4-BE49-F238E27FC236}">
+                <a16:creationId xmlns:a16="http://schemas.microsoft.com/office/drawing/2014/main" id="{5D98E177-C354-D542-A14E-E86EEC9F17A0}"/>
+              </a:ext>
+            </a:extLst>
+          </p:cNvPr>
+          <p:cNvSpPr>
+            <a:spLocks noGrp="1"/>
+          </p:cNvSpPr>
+          <p:nvPr>
+            <p:ph idx="1"/>
+          </p:nvPr>
+        </p:nvSpPr>
         <p:spPr/>
         <p:txBody>
           <a:bodyPr/>
           <a:lstStyle/>
           <a:p>
-            <a:r>
-              <a:rPr lang="en-US" dirty="0"/>
-              <a:t>Install </a:t>
-            </a:r>
-            <a:r>
-              <a:rPr lang="en-US" dirty="0" err="1"/>
-              <a:t>apktool</a:t>
-            </a:r>
-            <a:r>
-              <a:rPr lang="en-US" dirty="0"/>
-              <a:t> &amp; dex2jar</a:t>
-            </a:r>
-          </a:p>
-        </p:txBody>
-      </p:sp>
-      <p:sp>
-        <p:nvSpPr>
-          <p:cNvPr id="3" name="Tijdelijke aanduiding voor inhoud 2">
-            <a:extLst>
-              <a:ext uri="{FF2B5EF4-FFF2-40B4-BE49-F238E27FC236}">
-                <a16:creationId xmlns:a16="http://schemas.microsoft.com/office/drawing/2014/main" id="{7C0E6BAD-EEEE-5D48-91D0-4F92C151008F}"/>
-              </a:ext>
-            </a:extLst>
-          </p:cNvPr>
-          <p:cNvSpPr>
-            <a:spLocks noGrp="1"/>
-          </p:cNvSpPr>
-          <p:nvPr>
-            <p:ph idx="1"/>
-          </p:nvPr>
-        </p:nvSpPr>
-        <p:spPr/>
-        <p:txBody>
-          <a:bodyPr/>
-          <a:lstStyle/>
-          <a:p>
-            <a:r>
-              <a:rPr lang="en-US" dirty="0" err="1"/>
-              <a:t>Apktool</a:t>
-            </a:r>
-            <a:r>
-              <a:rPr lang="en-US" dirty="0"/>
-              <a:t>: </a:t>
-            </a:r>
-            <a:r>
-              <a:rPr lang="en-US" dirty="0">
-                <a:hlinkClick r:id="rId2"/>
-              </a:rPr>
-              <a:t>https://ibotpeaches.github.io/Apktool/install/</a:t>
-            </a:r>
-            <a:endParaRPr lang="en-US" dirty="0"/>
-          </a:p>
-          <a:p>
-            <a:r>
-              <a:rPr lang="en-US" dirty="0"/>
-              <a:t>Dex2jar: </a:t>
-            </a:r>
-            <a:r>
-              <a:rPr lang="en-US" dirty="0">
-                <a:hlinkClick r:id="rId3"/>
-              </a:rPr>
-              <a:t>https://github.com/pxb1988/dex2jar</a:t>
-            </a:r>
-            <a:endParaRPr lang="en-US" dirty="0"/>
-          </a:p>
-          <a:p>
-            <a:r>
-              <a:rPr lang="en-US" dirty="0" err="1"/>
-              <a:t>Jadx</a:t>
-            </a:r>
-            <a:r>
-              <a:rPr lang="en-US" dirty="0"/>
-              <a:t>: </a:t>
-            </a:r>
-            <a:r>
-              <a:rPr lang="en-US" dirty="0">
-                <a:hlinkClick r:id="rId4"/>
-              </a:rPr>
-              <a:t>https://github.com/skylot/jadx</a:t>
-            </a:r>
-            <a:r>
-              <a:rPr lang="en-US" dirty="0"/>
-              <a:t> </a:t>
-            </a:r>
-          </a:p>
-          <a:p>
-            <a:r>
-              <a:rPr lang="en-US" dirty="0" err="1"/>
-              <a:t>apkx</a:t>
-            </a:r>
-            <a:r>
-              <a:rPr lang="en-US" dirty="0"/>
-              <a:t>: </a:t>
-            </a:r>
-            <a:r>
-              <a:rPr lang="en-US" dirty="0">
-                <a:hlinkClick r:id="rId5"/>
-              </a:rPr>
-              <a:t>https://github.com/b-mueller/apkx</a:t>
-            </a:r>
             <a:endParaRPr lang="en-US"/>
           </a:p>
           <a:p>
-            <a:pPr marL="0" indent="0">
-              <a:buNone/>
-            </a:pPr>
-            <a:endParaRPr lang="en-US" dirty="0"/>
-          </a:p>
-        </p:txBody>
-      </p:sp>
+            <a:endParaRPr lang="en-US"/>
+          </a:p>
+        </p:txBody>
+      </p:sp>
+      <p:pic>
+        <p:nvPicPr>
+          <p:cNvPr id="4" name="Picture 3">
+            <a:extLst>
+              <a:ext uri="{FF2B5EF4-FFF2-40B4-BE49-F238E27FC236}">
+                <a16:creationId xmlns:a16="http://schemas.microsoft.com/office/drawing/2014/main" id="{968B3877-D59A-A84F-8393-96F5655C4C79}"/>
+              </a:ext>
+            </a:extLst>
+          </p:cNvPr>
+          <p:cNvPicPr>
+            <a:picLocks noChangeAspect="1"/>
+          </p:cNvPicPr>
+          <p:nvPr/>
+        </p:nvPicPr>
+        <p:blipFill>
+          <a:blip r:embed="rId2"/>
+          <a:stretch>
+            <a:fillRect/>
+          </a:stretch>
+        </p:blipFill>
+        <p:spPr>
+          <a:xfrm>
+            <a:off x="1129553" y="1298307"/>
+            <a:ext cx="9403462" cy="5405973"/>
+          </a:xfrm>
+          <a:prstGeom prst="rect">
+            <a:avLst/>
+          </a:prstGeom>
+        </p:spPr>
+      </p:pic>
     </p:spTree>
     <p:extLst>
       <p:ext uri="{BB962C8B-B14F-4D97-AF65-F5344CB8AC3E}">
-        <p14:creationId xmlns:p14="http://schemas.microsoft.com/office/powerpoint/2010/main" val="3995245116"/>
+        <p14:creationId xmlns:p14="http://schemas.microsoft.com/office/powerpoint/2010/main" val="4024758949"/>
       </p:ext>
     </p:extLst>
   </p:cSld>
@@ -4899,10 +4909,10 @@
       </p:grpSpPr>
       <p:sp>
         <p:nvSpPr>
-          <p:cNvPr id="2" name="Title 1">
-            <a:extLst>
-              <a:ext uri="{FF2B5EF4-FFF2-40B4-BE49-F238E27FC236}">
-                <a16:creationId xmlns:a16="http://schemas.microsoft.com/office/drawing/2014/main" id="{93966762-C3A5-3C4D-A279-EF6ECE00A35F}"/>
+          <p:cNvPr id="2" name="Titel 1">
+            <a:extLst>
+              <a:ext uri="{FF2B5EF4-FFF2-40B4-BE49-F238E27FC236}">
+                <a16:creationId xmlns:a16="http://schemas.microsoft.com/office/drawing/2014/main" id="{0E1A5BE2-2C25-DF4B-A390-A96416A96624}"/>
               </a:ext>
             </a:extLst>
           </p:cNvPr>
@@ -4913,31 +4923,32 @@
             <p:ph type="title"/>
           </p:nvPr>
         </p:nvSpPr>
-        <p:spPr>
-          <a:xfrm>
-            <a:off x="838200" y="85427"/>
-            <a:ext cx="10866120" cy="1325563"/>
-          </a:xfrm>
-        </p:spPr>
-        <p:txBody>
-          <a:bodyPr>
-            <a:normAutofit/>
-          </a:bodyPr>
-          <a:lstStyle/>
-          <a:p>
-            <a:r>
-              <a:rPr lang="en-US" sz="3600" dirty="0"/>
-              <a:t>OPTIONAL PART</a:t>
-            </a:r>
-          </a:p>
-        </p:txBody>
-      </p:sp>
-      <p:sp>
-        <p:nvSpPr>
-          <p:cNvPr id="3" name="Content Placeholder 2">
-            <a:extLst>
-              <a:ext uri="{FF2B5EF4-FFF2-40B4-BE49-F238E27FC236}">
-                <a16:creationId xmlns:a16="http://schemas.microsoft.com/office/drawing/2014/main" id="{5D98E177-C354-D542-A14E-E86EEC9F17A0}"/>
+        <p:spPr/>
+        <p:txBody>
+          <a:bodyPr/>
+          <a:lstStyle/>
+          <a:p>
+            <a:r>
+              <a:rPr lang="en-US" dirty="0"/>
+              <a:t>Install </a:t>
+            </a:r>
+            <a:r>
+              <a:rPr lang="en-US" dirty="0" err="1"/>
+              <a:t>apktool</a:t>
+            </a:r>
+            <a:r>
+              <a:rPr lang="en-US" dirty="0"/>
+              <a:t> &amp; dex2jar</a:t>
+            </a:r>
+          </a:p>
+        </p:txBody>
+      </p:sp>
+      <p:sp>
+        <p:nvSpPr>
+          <p:cNvPr id="3" name="Tijdelijke aanduiding voor inhoud 2">
+            <a:extLst>
+              <a:ext uri="{FF2B5EF4-FFF2-40B4-BE49-F238E27FC236}">
+                <a16:creationId xmlns:a16="http://schemas.microsoft.com/office/drawing/2014/main" id="{7C0E6BAD-EEEE-5D48-91D0-4F92C151008F}"/>
               </a:ext>
             </a:extLst>
           </p:cNvPr>
@@ -4953,20 +4964,84 @@
           <a:bodyPr/>
           <a:lstStyle/>
           <a:p>
-            <a:pPr marL="0" indent="0">
-              <a:buNone/>
-            </a:pPr>
+            <a:r>
+              <a:rPr lang="en-US" dirty="0" err="1"/>
+              <a:t>Apktool</a:t>
+            </a:r>
             <a:r>
               <a:rPr lang="en-US" dirty="0"/>
-              <a:t>This is not needed for the workshop but should be done if you want to explore HTTPS traffic with Burp!</a:t>
-            </a:r>
+              <a:t>: </a:t>
+            </a:r>
+            <a:r>
+              <a:rPr lang="en-US" dirty="0">
+                <a:hlinkClick r:id="rId2"/>
+              </a:rPr>
+              <a:t>https://ibotpeaches.github.io/Apktool/install/</a:t>
+            </a:r>
+            <a:endParaRPr lang="en-US" dirty="0"/>
+          </a:p>
+          <a:p>
+            <a:r>
+              <a:rPr lang="en-US" dirty="0"/>
+              <a:t>Dex2jar: </a:t>
+            </a:r>
+            <a:r>
+              <a:rPr lang="en-US" dirty="0">
+                <a:hlinkClick r:id="rId3"/>
+              </a:rPr>
+              <a:t>https://github.com/pxb1988/dex2jar</a:t>
+            </a:r>
+            <a:endParaRPr lang="en-US" dirty="0"/>
+          </a:p>
+          <a:p>
+            <a:r>
+              <a:rPr lang="en-US" dirty="0" err="1"/>
+              <a:t>Jadx</a:t>
+            </a:r>
+            <a:r>
+              <a:rPr lang="en-US" dirty="0"/>
+              <a:t>: </a:t>
+            </a:r>
+            <a:r>
+              <a:rPr lang="en-US" dirty="0">
+                <a:hlinkClick r:id="rId4"/>
+              </a:rPr>
+              <a:t>https://github.com/skylot/jadx</a:t>
+            </a:r>
+            <a:r>
+              <a:rPr lang="en-US" dirty="0"/>
+              <a:t> </a:t>
+            </a:r>
+          </a:p>
+          <a:p>
+            <a:r>
+              <a:rPr lang="en-US" dirty="0" err="1"/>
+              <a:t>apkx</a:t>
+            </a:r>
+            <a:r>
+              <a:rPr lang="en-US" dirty="0"/>
+              <a:t>: </a:t>
+            </a:r>
+            <a:r>
+              <a:rPr lang="en-US" dirty="0">
+                <a:hlinkClick r:id="rId5"/>
+              </a:rPr>
+              <a:t>https://github.com/b-mueller/apkx</a:t>
+            </a:r>
+            <a:endParaRPr lang="en-US"/>
+          </a:p>
+          <a:p>
+            <a:pPr marL="0" indent="0">
+              <a:buNone/>
+            </a:pPr>
+            <a:endParaRPr lang="en-US" dirty="0"/>
           </a:p>
         </p:txBody>
       </p:sp>
     </p:spTree>
     <p:extLst>
       <p:ext uri="{BB962C8B-B14F-4D97-AF65-F5344CB8AC3E}">
-        <p14:creationId xmlns:p14="http://schemas.microsoft.com/office/powerpoint/2010/main" val="1820042251"/>
+        <p14:creationId xmlns:p14="http://schemas.microsoft.com/office/powerpoint/2010/main" val="3995245116"/>
       </p:ext>
     </p:extLst>
   </p:cSld>
@@ -5022,8 +5097,8 @@
           <a:lstStyle/>
           <a:p>
             <a:r>
-              <a:rPr lang="en-US" sz="3600"/>
-              <a:t>Prepare the CA Certificate of Burp </a:t>
+              <a:rPr lang="en-US" sz="3600" dirty="0"/>
+              <a:t>OPTIONAL PART</a:t>
             </a:r>
           </a:p>
         </p:txBody>
@@ -5044,222 +5119,25 @@
             <p:ph idx="1"/>
           </p:nvPr>
         </p:nvSpPr>
-        <p:spPr>
-          <a:xfrm>
-            <a:off x="838200" y="1410990"/>
-            <a:ext cx="10515600" cy="4351338"/>
-          </a:xfrm>
-        </p:spPr>
-        <p:txBody>
-          <a:bodyPr>
-            <a:noAutofit/>
-          </a:bodyPr>
-          <a:lstStyle/>
-          <a:p>
-            <a:pPr marL="0" indent="0">
-              <a:buNone/>
-            </a:pPr>
-            <a:r>
-              <a:rPr lang="en-US" sz="2000"/>
-              <a:t>Open ”Proxy/Options” and click on Import/Export CA Certificate” and export it in der format. </a:t>
-            </a:r>
-          </a:p>
-          <a:p>
-            <a:pPr marL="0" indent="0">
-              <a:buNone/>
-            </a:pPr>
-            <a:r>
-              <a:rPr lang="en-US" sz="2000"/>
-              <a:t>Save the file as “</a:t>
-            </a:r>
-            <a:r>
-              <a:rPr lang="en-US" sz="2000" err="1"/>
-              <a:t>burp.cer</a:t>
-            </a:r>
-            <a:r>
-              <a:rPr lang="en-US" sz="2000"/>
-              <a:t>” </a:t>
-            </a:r>
-            <a:r>
-              <a:rPr lang="en-US" sz="2000" b="1"/>
-              <a:t>(NOT DER!)</a:t>
-            </a:r>
-            <a:r>
-              <a:rPr lang="en-US" sz="2000"/>
-              <a:t> </a:t>
-            </a:r>
-          </a:p>
-          <a:p>
-            <a:pPr marL="0" indent="0">
-              <a:buNone/>
-            </a:pPr>
-            <a:endParaRPr lang="en-US" sz="2000"/>
-          </a:p>
-          <a:p>
-            <a:pPr marL="0" indent="0">
-              <a:buNone/>
-            </a:pPr>
-            <a:endParaRPr lang="en-US" sz="2000"/>
-          </a:p>
-          <a:p>
-            <a:pPr marL="0" indent="0">
-              <a:buNone/>
-            </a:pPr>
-            <a:endParaRPr lang="en-US" sz="2000"/>
-          </a:p>
-          <a:p>
-            <a:pPr marL="0" indent="0">
-              <a:buNone/>
-            </a:pPr>
-            <a:endParaRPr lang="en-US" sz="2000"/>
-          </a:p>
-          <a:p>
-            <a:pPr marL="0" indent="0">
-              <a:buNone/>
-            </a:pPr>
-            <a:endParaRPr lang="en-US" sz="2000"/>
-          </a:p>
-          <a:p>
-            <a:pPr marL="0" indent="0">
-              <a:buNone/>
-            </a:pPr>
-            <a:endParaRPr lang="en-US" sz="2000"/>
-          </a:p>
-          <a:p>
-            <a:pPr marL="0" indent="0">
-              <a:buNone/>
-            </a:pPr>
-            <a:endParaRPr lang="en-US" sz="2000"/>
-          </a:p>
-          <a:p>
-            <a:pPr marL="0" indent="0">
-              <a:buNone/>
-            </a:pPr>
-            <a:endParaRPr lang="en-US" sz="2000"/>
-          </a:p>
-          <a:p>
-            <a:pPr marL="0" indent="0">
-              <a:buNone/>
-            </a:pPr>
-            <a:endParaRPr lang="en-US" sz="2000"/>
-          </a:p>
-          <a:p>
-            <a:pPr marL="0" indent="0">
-              <a:buNone/>
-            </a:pPr>
-            <a:r>
-              <a:rPr lang="en-US" sz="2000"/>
-              <a:t>Next push this certificate to the Emulator</a:t>
-            </a:r>
-          </a:p>
-          <a:p>
-            <a:pPr marL="0" indent="0">
-              <a:buNone/>
-            </a:pPr>
-            <a:endParaRPr lang="en-US" sz="2000"/>
-          </a:p>
-          <a:p>
-            <a:pPr marL="0" indent="0">
-              <a:buNone/>
-            </a:pPr>
-            <a:endParaRPr lang="en-US" sz="2000"/>
-          </a:p>
-        </p:txBody>
-      </p:sp>
-      <p:pic>
-        <p:nvPicPr>
-          <p:cNvPr id="5" name="Picture 4">
-            <a:extLst>
-              <a:ext uri="{FF2B5EF4-FFF2-40B4-BE49-F238E27FC236}">
-                <a16:creationId xmlns:a16="http://schemas.microsoft.com/office/drawing/2014/main" id="{C9EF747D-142A-1F45-BF48-1C9F7404DA82}"/>
-              </a:ext>
-            </a:extLst>
-          </p:cNvPr>
-          <p:cNvPicPr>
-            <a:picLocks noChangeAspect="1"/>
-          </p:cNvPicPr>
-          <p:nvPr/>
-        </p:nvPicPr>
-        <p:blipFill>
-          <a:blip r:embed="rId2"/>
-          <a:stretch>
-            <a:fillRect/>
-          </a:stretch>
-        </p:blipFill>
-        <p:spPr>
-          <a:xfrm>
-            <a:off x="838200" y="2553630"/>
-            <a:ext cx="6785919" cy="2900264"/>
-          </a:xfrm>
-          <a:prstGeom prst="rect">
-            <a:avLst/>
-          </a:prstGeom>
-        </p:spPr>
-      </p:pic>
-      <p:pic>
-        <p:nvPicPr>
-          <p:cNvPr id="6" name="Picture 5">
-            <a:extLst>
-              <a:ext uri="{FF2B5EF4-FFF2-40B4-BE49-F238E27FC236}">
-                <a16:creationId xmlns:a16="http://schemas.microsoft.com/office/drawing/2014/main" id="{A11DFFAD-F730-BA41-AD44-F19335C7BFFB}"/>
-              </a:ext>
-            </a:extLst>
-          </p:cNvPr>
-          <p:cNvPicPr>
-            <a:picLocks noChangeAspect="1"/>
-          </p:cNvPicPr>
-          <p:nvPr/>
-        </p:nvPicPr>
-        <p:blipFill>
-          <a:blip r:embed="rId3"/>
-          <a:stretch>
-            <a:fillRect/>
-          </a:stretch>
-        </p:blipFill>
-        <p:spPr>
-          <a:xfrm>
-            <a:off x="838200" y="6233196"/>
-            <a:ext cx="6235700" cy="596900"/>
-          </a:xfrm>
-          <a:prstGeom prst="rect">
-            <a:avLst/>
-          </a:prstGeom>
-        </p:spPr>
-      </p:pic>
-      <p:pic>
-        <p:nvPicPr>
-          <p:cNvPr id="7" name="Picture 6">
-            <a:extLst>
-              <a:ext uri="{FF2B5EF4-FFF2-40B4-BE49-F238E27FC236}">
-                <a16:creationId xmlns:a16="http://schemas.microsoft.com/office/drawing/2014/main" id="{BA95E2CF-EC72-B54A-B1E4-D632CD8D36E6}"/>
-              </a:ext>
-            </a:extLst>
-          </p:cNvPr>
-          <p:cNvPicPr>
-            <a:picLocks noChangeAspect="1"/>
-          </p:cNvPicPr>
-          <p:nvPr/>
-        </p:nvPicPr>
-        <p:blipFill>
-          <a:blip r:embed="rId4"/>
-          <a:stretch>
-            <a:fillRect/>
-          </a:stretch>
-        </p:blipFill>
-        <p:spPr>
-          <a:xfrm>
-            <a:off x="7757151" y="2279900"/>
-            <a:ext cx="5011486" cy="3447724"/>
-          </a:xfrm>
-          <a:prstGeom prst="rect">
-            <a:avLst/>
-          </a:prstGeom>
-        </p:spPr>
-      </p:pic>
+        <p:spPr/>
+        <p:txBody>
+          <a:bodyPr/>
+          <a:lstStyle/>
+          <a:p>
+            <a:pPr marL="0" indent="0">
+              <a:buNone/>
+            </a:pPr>
+            <a:r>
+              <a:rPr lang="en-US" dirty="0"/>
+              <a:t>This is not needed for the workshop but should be done if you want to explore HTTPS traffic with Burp!</a:t>
+            </a:r>
+          </a:p>
+        </p:txBody>
+      </p:sp>
     </p:spTree>
     <p:extLst>
       <p:ext uri="{BB962C8B-B14F-4D97-AF65-F5344CB8AC3E}">
-        <p14:creationId xmlns:p14="http://schemas.microsoft.com/office/powerpoint/2010/main" val="3098322161"/>
+        <p14:creationId xmlns:p14="http://schemas.microsoft.com/office/powerpoint/2010/main" val="1820042251"/>
       </p:ext>
     </p:extLst>
   </p:cSld>
@@ -5489,6 +5367,299 @@
               <a:buNone/>
             </a:pPr>
             <a:r>
+              <a:rPr lang="en-US" sz="2000"/>
+              <a:t>Open ”Proxy/Options” and click on Import/Export CA Certificate” and export it in der format. </a:t>
+            </a:r>
+          </a:p>
+          <a:p>
+            <a:pPr marL="0" indent="0">
+              <a:buNone/>
+            </a:pPr>
+            <a:r>
+              <a:rPr lang="en-US" sz="2000"/>
+              <a:t>Save the file as “</a:t>
+            </a:r>
+            <a:r>
+              <a:rPr lang="en-US" sz="2000" err="1"/>
+              <a:t>burp.cer</a:t>
+            </a:r>
+            <a:r>
+              <a:rPr lang="en-US" sz="2000"/>
+              <a:t>” </a:t>
+            </a:r>
+            <a:r>
+              <a:rPr lang="en-US" sz="2000" b="1"/>
+              <a:t>(NOT DER!)</a:t>
+            </a:r>
+            <a:r>
+              <a:rPr lang="en-US" sz="2000"/>
+              <a:t> </a:t>
+            </a:r>
+          </a:p>
+          <a:p>
+            <a:pPr marL="0" indent="0">
+              <a:buNone/>
+            </a:pPr>
+            <a:endParaRPr lang="en-US" sz="2000"/>
+          </a:p>
+          <a:p>
+            <a:pPr marL="0" indent="0">
+              <a:buNone/>
+            </a:pPr>
+            <a:endParaRPr lang="en-US" sz="2000"/>
+          </a:p>
+          <a:p>
+            <a:pPr marL="0" indent="0">
+              <a:buNone/>
+            </a:pPr>
+            <a:endParaRPr lang="en-US" sz="2000"/>
+          </a:p>
+          <a:p>
+            <a:pPr marL="0" indent="0">
+              <a:buNone/>
+            </a:pPr>
+            <a:endParaRPr lang="en-US" sz="2000"/>
+          </a:p>
+          <a:p>
+            <a:pPr marL="0" indent="0">
+              <a:buNone/>
+            </a:pPr>
+            <a:endParaRPr lang="en-US" sz="2000"/>
+          </a:p>
+          <a:p>
+            <a:pPr marL="0" indent="0">
+              <a:buNone/>
+            </a:pPr>
+            <a:endParaRPr lang="en-US" sz="2000"/>
+          </a:p>
+          <a:p>
+            <a:pPr marL="0" indent="0">
+              <a:buNone/>
+            </a:pPr>
+            <a:endParaRPr lang="en-US" sz="2000"/>
+          </a:p>
+          <a:p>
+            <a:pPr marL="0" indent="0">
+              <a:buNone/>
+            </a:pPr>
+            <a:endParaRPr lang="en-US" sz="2000"/>
+          </a:p>
+          <a:p>
+            <a:pPr marL="0" indent="0">
+              <a:buNone/>
+            </a:pPr>
+            <a:endParaRPr lang="en-US" sz="2000"/>
+          </a:p>
+          <a:p>
+            <a:pPr marL="0" indent="0">
+              <a:buNone/>
+            </a:pPr>
+            <a:r>
+              <a:rPr lang="en-US" sz="2000"/>
+              <a:t>Next push this certificate to the Emulator</a:t>
+            </a:r>
+          </a:p>
+          <a:p>
+            <a:pPr marL="0" indent="0">
+              <a:buNone/>
+            </a:pPr>
+            <a:endParaRPr lang="en-US" sz="2000"/>
+          </a:p>
+          <a:p>
+            <a:pPr marL="0" indent="0">
+              <a:buNone/>
+            </a:pPr>
+            <a:endParaRPr lang="en-US" sz="2000"/>
+          </a:p>
+        </p:txBody>
+      </p:sp>
+      <p:pic>
+        <p:nvPicPr>
+          <p:cNvPr id="5" name="Picture 4">
+            <a:extLst>
+              <a:ext uri="{FF2B5EF4-FFF2-40B4-BE49-F238E27FC236}">
+                <a16:creationId xmlns:a16="http://schemas.microsoft.com/office/drawing/2014/main" id="{C9EF747D-142A-1F45-BF48-1C9F7404DA82}"/>
+              </a:ext>
+            </a:extLst>
+          </p:cNvPr>
+          <p:cNvPicPr>
+            <a:picLocks noChangeAspect="1"/>
+          </p:cNvPicPr>
+          <p:nvPr/>
+        </p:nvPicPr>
+        <p:blipFill>
+          <a:blip r:embed="rId2"/>
+          <a:stretch>
+            <a:fillRect/>
+          </a:stretch>
+        </p:blipFill>
+        <p:spPr>
+          <a:xfrm>
+            <a:off x="838200" y="2553630"/>
+            <a:ext cx="6785919" cy="2900264"/>
+          </a:xfrm>
+          <a:prstGeom prst="rect">
+            <a:avLst/>
+          </a:prstGeom>
+        </p:spPr>
+      </p:pic>
+      <p:pic>
+        <p:nvPicPr>
+          <p:cNvPr id="6" name="Picture 5">
+            <a:extLst>
+              <a:ext uri="{FF2B5EF4-FFF2-40B4-BE49-F238E27FC236}">
+                <a16:creationId xmlns:a16="http://schemas.microsoft.com/office/drawing/2014/main" id="{A11DFFAD-F730-BA41-AD44-F19335C7BFFB}"/>
+              </a:ext>
+            </a:extLst>
+          </p:cNvPr>
+          <p:cNvPicPr>
+            <a:picLocks noChangeAspect="1"/>
+          </p:cNvPicPr>
+          <p:nvPr/>
+        </p:nvPicPr>
+        <p:blipFill>
+          <a:blip r:embed="rId3"/>
+          <a:stretch>
+            <a:fillRect/>
+          </a:stretch>
+        </p:blipFill>
+        <p:spPr>
+          <a:xfrm>
+            <a:off x="838200" y="6233196"/>
+            <a:ext cx="6235700" cy="596900"/>
+          </a:xfrm>
+          <a:prstGeom prst="rect">
+            <a:avLst/>
+          </a:prstGeom>
+        </p:spPr>
+      </p:pic>
+      <p:pic>
+        <p:nvPicPr>
+          <p:cNvPr id="7" name="Picture 6">
+            <a:extLst>
+              <a:ext uri="{FF2B5EF4-FFF2-40B4-BE49-F238E27FC236}">
+                <a16:creationId xmlns:a16="http://schemas.microsoft.com/office/drawing/2014/main" id="{BA95E2CF-EC72-B54A-B1E4-D632CD8D36E6}"/>
+              </a:ext>
+            </a:extLst>
+          </p:cNvPr>
+          <p:cNvPicPr>
+            <a:picLocks noChangeAspect="1"/>
+          </p:cNvPicPr>
+          <p:nvPr/>
+        </p:nvPicPr>
+        <p:blipFill>
+          <a:blip r:embed="rId4"/>
+          <a:stretch>
+            <a:fillRect/>
+          </a:stretch>
+        </p:blipFill>
+        <p:spPr>
+          <a:xfrm>
+            <a:off x="7757151" y="2279900"/>
+            <a:ext cx="5011486" cy="3447724"/>
+          </a:xfrm>
+          <a:prstGeom prst="rect">
+            <a:avLst/>
+          </a:prstGeom>
+        </p:spPr>
+      </p:pic>
+    </p:spTree>
+    <p:extLst>
+      <p:ext uri="{BB962C8B-B14F-4D97-AF65-F5344CB8AC3E}">
+        <p14:creationId xmlns:p14="http://schemas.microsoft.com/office/powerpoint/2010/main" val="3098322161"/>
+      </p:ext>
+    </p:extLst>
+  </p:cSld>
+  <p:clrMapOvr>
+    <a:masterClrMapping/>
+  </p:clrMapOvr>
+</p:sld>
+</file>
+
+<file path=ppt/slides/slide21.xml><?xml version="1.0" encoding="utf-8"?>
+<p:sld xmlns:a="http://schemas.openxmlformats.org/drawingml/2006/main" xmlns:r="http://schemas.openxmlformats.org/officeDocument/2006/relationships" xmlns:p="http://schemas.openxmlformats.org/presentationml/2006/main">
+  <p:cSld>
+    <p:spTree>
+      <p:nvGrpSpPr>
+        <p:cNvPr id="1" name=""/>
+        <p:cNvGrpSpPr/>
+        <p:nvPr/>
+      </p:nvGrpSpPr>
+      <p:grpSpPr>
+        <a:xfrm>
+          <a:off x="0" y="0"/>
+          <a:ext cx="0" cy="0"/>
+          <a:chOff x="0" y="0"/>
+          <a:chExt cx="0" cy="0"/>
+        </a:xfrm>
+      </p:grpSpPr>
+      <p:sp>
+        <p:nvSpPr>
+          <p:cNvPr id="2" name="Title 1">
+            <a:extLst>
+              <a:ext uri="{FF2B5EF4-FFF2-40B4-BE49-F238E27FC236}">
+                <a16:creationId xmlns:a16="http://schemas.microsoft.com/office/drawing/2014/main" id="{93966762-C3A5-3C4D-A279-EF6ECE00A35F}"/>
+              </a:ext>
+            </a:extLst>
+          </p:cNvPr>
+          <p:cNvSpPr>
+            <a:spLocks noGrp="1"/>
+          </p:cNvSpPr>
+          <p:nvPr>
+            <p:ph type="title"/>
+          </p:nvPr>
+        </p:nvSpPr>
+        <p:spPr>
+          <a:xfrm>
+            <a:off x="838200" y="85427"/>
+            <a:ext cx="10866120" cy="1325563"/>
+          </a:xfrm>
+        </p:spPr>
+        <p:txBody>
+          <a:bodyPr>
+            <a:normAutofit/>
+          </a:bodyPr>
+          <a:lstStyle/>
+          <a:p>
+            <a:r>
+              <a:rPr lang="en-US" sz="3600"/>
+              <a:t>Prepare the CA Certificate of Burp </a:t>
+            </a:r>
+          </a:p>
+        </p:txBody>
+      </p:sp>
+      <p:sp>
+        <p:nvSpPr>
+          <p:cNvPr id="3" name="Content Placeholder 2">
+            <a:extLst>
+              <a:ext uri="{FF2B5EF4-FFF2-40B4-BE49-F238E27FC236}">
+                <a16:creationId xmlns:a16="http://schemas.microsoft.com/office/drawing/2014/main" id="{5D98E177-C354-D542-A14E-E86EEC9F17A0}"/>
+              </a:ext>
+            </a:extLst>
+          </p:cNvPr>
+          <p:cNvSpPr>
+            <a:spLocks noGrp="1"/>
+          </p:cNvSpPr>
+          <p:nvPr>
+            <p:ph idx="1"/>
+          </p:nvPr>
+        </p:nvSpPr>
+        <p:spPr>
+          <a:xfrm>
+            <a:off x="838200" y="1410990"/>
+            <a:ext cx="10515600" cy="4351338"/>
+          </a:xfrm>
+        </p:spPr>
+        <p:txBody>
+          <a:bodyPr>
+            <a:noAutofit/>
+          </a:bodyPr>
+          <a:lstStyle/>
+          <a:p>
+            <a:pPr marL="0" indent="0">
+              <a:buNone/>
+            </a:pPr>
+            <a:r>
               <a:rPr lang="en-US" sz="2000" dirty="0"/>
               <a:t>Next we need to import the CA into our </a:t>
             </a:r>
@@ -5961,7 +6132,7 @@
 </p:sld>
 </file>
 
-<file path=ppt/slides/slide21.xml><?xml version="1.0" encoding="utf-8"?>
+<file path=ppt/slides/slide22.xml><?xml version="1.0" encoding="utf-8"?>
 <p:sld xmlns:a="http://schemas.openxmlformats.org/drawingml/2006/main" xmlns:r="http://schemas.openxmlformats.org/officeDocument/2006/relationships" xmlns:p="http://schemas.openxmlformats.org/presentationml/2006/main">
   <p:cSld>
     <p:spTree>
@@ -7509,7 +7680,7 @@
         </p:nvSpPr>
         <p:spPr>
           <a:xfrm>
-            <a:off x="838200" y="1825625"/>
+            <a:off x="838200" y="1414145"/>
             <a:ext cx="10515600" cy="4351338"/>
           </a:xfrm>
         </p:spPr>
@@ -7571,8 +7742,8 @@
         </p:blipFill>
         <p:spPr>
           <a:xfrm>
-            <a:off x="838200" y="2285280"/>
-            <a:ext cx="5186499" cy="4438349"/>
+            <a:off x="838201" y="1873800"/>
+            <a:ext cx="5013960" cy="4290699"/>
           </a:xfrm>
           <a:prstGeom prst="rect">
             <a:avLst/>
@@ -7581,10 +7752,10 @@
       </p:pic>
       <p:pic>
         <p:nvPicPr>
-          <p:cNvPr id="5" name="Picture 4">
-            <a:extLst>
-              <a:ext uri="{FF2B5EF4-FFF2-40B4-BE49-F238E27FC236}">
-                <a16:creationId xmlns:a16="http://schemas.microsoft.com/office/drawing/2014/main" id="{48068644-108A-7744-BFE0-9831CB6D37DC}"/>
+          <p:cNvPr id="9" name="Picture 8">
+            <a:extLst>
+              <a:ext uri="{FF2B5EF4-FFF2-40B4-BE49-F238E27FC236}">
+                <a16:creationId xmlns:a16="http://schemas.microsoft.com/office/drawing/2014/main" id="{ABE883A6-B44C-B040-B46F-7B77A0117BAC}"/>
               </a:ext>
             </a:extLst>
           </p:cNvPr>
@@ -7601,7 +7772,7 @@
         </p:blipFill>
         <p:spPr>
           <a:xfrm>
-            <a:off x="6820988" y="5321300"/>
+            <a:off x="6512650" y="4775449"/>
             <a:ext cx="5003800" cy="1536700"/>
           </a:xfrm>
           <a:prstGeom prst="rect">
@@ -7609,36 +7780,6 @@
           </a:prstGeom>
         </p:spPr>
       </p:pic>
-      <p:pic>
-        <p:nvPicPr>
-          <p:cNvPr id="9" name="Picture 8">
-            <a:extLst>
-              <a:ext uri="{FF2B5EF4-FFF2-40B4-BE49-F238E27FC236}">
-                <a16:creationId xmlns:a16="http://schemas.microsoft.com/office/drawing/2014/main" id="{ABE883A6-B44C-B040-B46F-7B77A0117BAC}"/>
-              </a:ext>
-            </a:extLst>
-          </p:cNvPr>
-          <p:cNvPicPr>
-            <a:picLocks noChangeAspect="1"/>
-          </p:cNvPicPr>
-          <p:nvPr/>
-        </p:nvPicPr>
-        <p:blipFill>
-          <a:blip r:embed="rId3"/>
-          <a:stretch>
-            <a:fillRect/>
-          </a:stretch>
-        </p:blipFill>
-        <p:spPr>
-          <a:xfrm>
-            <a:off x="6512650" y="5186929"/>
-            <a:ext cx="5003800" cy="1536700"/>
-          </a:xfrm>
-          <a:prstGeom prst="rect">
-            <a:avLst/>
-          </a:prstGeom>
-        </p:spPr>
-      </p:pic>
       <p:sp>
         <p:nvSpPr>
           <p:cNvPr id="6" name="TextBox 5">
@@ -7653,7 +7794,7 @@
         </p:nvSpPr>
         <p:spPr>
           <a:xfrm>
-            <a:off x="6583680" y="4820194"/>
+            <a:off x="6583680" y="4408714"/>
             <a:ext cx="5262018" cy="369332"/>
           </a:xfrm>
           <a:prstGeom prst="rect">
@@ -7696,7 +7837,7 @@
         </p:blipFill>
         <p:spPr>
           <a:xfrm>
-            <a:off x="6543403" y="3036089"/>
+            <a:off x="6543403" y="2624609"/>
             <a:ext cx="5281385" cy="1649168"/>
           </a:xfrm>
           <a:prstGeom prst="rect">
@@ -7718,7 +7859,7 @@
         </p:nvSpPr>
         <p:spPr>
           <a:xfrm>
-            <a:off x="6512650" y="2483390"/>
+            <a:off x="6512650" y="2071910"/>
             <a:ext cx="5262018" cy="369332"/>
           </a:xfrm>
           <a:prstGeom prst="rect">
@@ -7735,6 +7876,65 @@
             <a:r>
               <a:rPr lang="en-US" dirty="0"/>
               <a:t>Change the path to your actual path on your machine:</a:t>
+            </a:r>
+          </a:p>
+        </p:txBody>
+      </p:sp>
+      <p:sp>
+        <p:nvSpPr>
+          <p:cNvPr id="4" name="TextBox 3">
+            <a:extLst>
+              <a:ext uri="{FF2B5EF4-FFF2-40B4-BE49-F238E27FC236}">
+                <a16:creationId xmlns:a16="http://schemas.microsoft.com/office/drawing/2014/main" id="{C9D40C82-950A-3D42-A4D7-459375B3D0E1}"/>
+              </a:ext>
+            </a:extLst>
+          </p:cNvPr>
+          <p:cNvSpPr txBox="1"/>
+          <p:nvPr/>
+        </p:nvSpPr>
+        <p:spPr>
+          <a:xfrm>
+            <a:off x="723900" y="6222687"/>
+            <a:ext cx="7647222" cy="646331"/>
+          </a:xfrm>
+          <a:prstGeom prst="rect">
+            <a:avLst/>
+          </a:prstGeom>
+          <a:noFill/>
+        </p:spPr>
+        <p:txBody>
+          <a:bodyPr wrap="none" rtlCol="0">
+            <a:spAutoFit/>
+          </a:bodyPr>
+          <a:lstStyle/>
+          <a:p>
+            <a:r>
+              <a:rPr lang="en-US" b="1" dirty="0"/>
+              <a:t>For Windows Users: </a:t>
+            </a:r>
+            <a:r>
+              <a:rPr lang="en-US" dirty="0"/>
+              <a:t>You can find the .</a:t>
+            </a:r>
+            <a:r>
+              <a:rPr lang="en-US" dirty="0" err="1"/>
+              <a:t>avd</a:t>
+            </a:r>
+            <a:r>
+              <a:rPr lang="en-US" dirty="0"/>
+              <a:t> directory here </a:t>
+            </a:r>
+          </a:p>
+          <a:p>
+            <a:r>
+              <a:rPr lang="en-US" dirty="0">
+                <a:hlinkClick r:id="rId5"/>
+              </a:rPr>
+              <a:t>https://developer.android.com/studio/run/emulator-commandline#data-filedir</a:t>
+            </a:r>
+            <a:r>
+              <a:rPr lang="en-US" dirty="0"/>
+              <a:t> </a:t>
             </a:r>
           </a:p>
         </p:txBody>

</xml_diff>

<commit_message>
Updated bay area presentation
</commit_message>
<xml_diff>
--- a/Preparation-Bay-Area-Workshop.pptx
+++ b/Preparation-Bay-Area-Workshop.pptx
@@ -5044,6 +5044,27 @@
             </a:r>
           </a:p>
           <a:p>
+            <a:r>
+              <a:rPr lang="nl-NL" dirty="0" err="1"/>
+              <a:t>Wireshark</a:t>
+            </a:r>
+            <a:r>
+              <a:rPr lang="nl-NL" dirty="0"/>
+              <a:t>: </a:t>
+            </a:r>
+            <a:r>
+              <a:rPr lang="nl-NL" dirty="0">
+                <a:hlinkClick r:id="rId7"/>
+              </a:rPr>
+              <a:t>https://www.wireshark.org</a:t>
+            </a:r>
+            <a:r>
+              <a:rPr lang="nl-NL"/>
+              <a:t> </a:t>
+            </a:r>
+            <a:endParaRPr lang="nl-NL" dirty="0"/>
+          </a:p>
+          <a:p>
             <a:endParaRPr lang="en-US" dirty="0"/>
           </a:p>
           <a:p>

</xml_diff>

<commit_message>
added final prepration slides
</commit_message>
<xml_diff>
--- a/Preparation-Bay-Area-Workshop.pptx
+++ b/Preparation-Bay-Area-Workshop.pptx
@@ -5059,9 +5059,37 @@
               <a:t>https://www.wireshark.org</a:t>
             </a:r>
             <a:r>
+              <a:rPr lang="nl-NL" dirty="0"/>
+              <a:t> </a:t>
+            </a:r>
+          </a:p>
+          <a:p>
+            <a:r>
+              <a:rPr lang="nl-NL" dirty="0" err="1"/>
+              <a:t>Needle</a:t>
+            </a:r>
+            <a:r>
+              <a:rPr lang="nl-NL" dirty="0"/>
+              <a:t>: </a:t>
+            </a:r>
+            <a:r>
+              <a:rPr lang="nl-NL" dirty="0">
+                <a:hlinkClick r:id="rId8"/>
+              </a:rPr>
+              <a:t>https://github.com/mwrlabs/needle</a:t>
+            </a:r>
+            <a:r>
+              <a:rPr lang="nl-NL">
+                <a:hlinkClick r:id="rId8"/>
+              </a:rPr>
+              <a:t>/wiki/Installation-Guide</a:t>
+            </a:r>
+            <a:r>
               <a:rPr lang="nl-NL"/>
               <a:t> </a:t>
             </a:r>
+          </a:p>
+          <a:p>
             <a:endParaRPr lang="nl-NL" dirty="0"/>
           </a:p>
           <a:p>

</xml_diff>